<commit_message>
prune palette-swap theme styles
</commit_message>
<xml_diff>
--- a/docs/assets/readme-teaser/deck.pptx
+++ b/docs/assets/readme-teaser/deck.pptx
@@ -290,7 +290,7 @@
           <c:spPr>
             <a:ln w="12700" cap="flat">
               <a:solidFill>
-                <a:srgbClr val="BCCDD8"/>
+                <a:srgbClr val="D1DFE6"/>
               </a:solidFill>
               <a:prstDash val="solid"/>
               <a:round/>
@@ -1129,17 +1129,19 @@
         </p:nvSpPr>
         <p:spPr>
           <a:xfrm>
-            <a:off x="658368" y="420624"/>
-            <a:ext cx="0" cy="6053328"/>
-          </a:xfrm>
-          <a:prstGeom prst="line">
-            <a:avLst/>
-          </a:prstGeom>
-          <a:noFill/>
+            <a:off x="731520" y="1207008"/>
+            <a:ext cx="1325880" cy="54864"/>
+          </a:xfrm>
+          <a:prstGeom prst="rect">
+            <a:avLst/>
+          </a:prstGeom>
+          <a:solidFill>
+            <a:srgbClr val="9E4C0F"/>
+          </a:solidFill>
           <a:ln w="12700">
             <a:solidFill>
-              <a:srgbClr val="BCCDD8">
-                <a:alpha val="70000"/>
+              <a:srgbClr val="9E4C0F">
+                <a:alpha val="0"/>
               </a:srgbClr>
             </a:solidFill>
             <a:prstDash val="solid"/>
@@ -1154,283 +1156,8 @@
         </p:nvSpPr>
         <p:spPr>
           <a:xfrm>
-            <a:off x="2470861" y="420624"/>
-            <a:ext cx="0" cy="6053328"/>
-          </a:xfrm>
-          <a:prstGeom prst="line">
-            <a:avLst/>
-          </a:prstGeom>
-          <a:noFill/>
-          <a:ln w="12700">
-            <a:solidFill>
-              <a:srgbClr val="BCCDD8">
-                <a:alpha val="38000"/>
-              </a:srgbClr>
-            </a:solidFill>
-            <a:prstDash val="solid"/>
-          </a:ln>
-        </p:spPr>
-      </p:sp>
-      <p:sp>
-        <p:nvSpPr>
-          <p:cNvPr id="4" name="Shape 2"/>
-          <p:cNvSpPr/>
-          <p:nvPr/>
-        </p:nvSpPr>
-        <p:spPr>
-          <a:xfrm>
-            <a:off x="4283354" y="420624"/>
-            <a:ext cx="0" cy="6053328"/>
-          </a:xfrm>
-          <a:prstGeom prst="line">
-            <a:avLst/>
-          </a:prstGeom>
-          <a:noFill/>
-          <a:ln w="12700">
-            <a:solidFill>
-              <a:srgbClr val="BCCDD8">
-                <a:alpha val="70000"/>
-              </a:srgbClr>
-            </a:solidFill>
-            <a:prstDash val="solid"/>
-          </a:ln>
-        </p:spPr>
-      </p:sp>
-      <p:sp>
-        <p:nvSpPr>
-          <p:cNvPr id="5" name="Shape 3"/>
-          <p:cNvSpPr/>
-          <p:nvPr/>
-        </p:nvSpPr>
-        <p:spPr>
-          <a:xfrm>
-            <a:off x="6095848" y="420624"/>
-            <a:ext cx="0" cy="6053328"/>
-          </a:xfrm>
-          <a:prstGeom prst="line">
-            <a:avLst/>
-          </a:prstGeom>
-          <a:noFill/>
-          <a:ln w="12700">
-            <a:solidFill>
-              <a:srgbClr val="BCCDD8">
-                <a:alpha val="38000"/>
-              </a:srgbClr>
-            </a:solidFill>
-            <a:prstDash val="solid"/>
-          </a:ln>
-        </p:spPr>
-      </p:sp>
-      <p:sp>
-        <p:nvSpPr>
-          <p:cNvPr id="6" name="Shape 4"/>
-          <p:cNvSpPr/>
-          <p:nvPr/>
-        </p:nvSpPr>
-        <p:spPr>
-          <a:xfrm>
-            <a:off x="7908341" y="420624"/>
-            <a:ext cx="0" cy="6053328"/>
-          </a:xfrm>
-          <a:prstGeom prst="line">
-            <a:avLst/>
-          </a:prstGeom>
-          <a:noFill/>
-          <a:ln w="12700">
-            <a:solidFill>
-              <a:srgbClr val="BCCDD8">
-                <a:alpha val="70000"/>
-              </a:srgbClr>
-            </a:solidFill>
-            <a:prstDash val="solid"/>
-          </a:ln>
-        </p:spPr>
-      </p:sp>
-      <p:sp>
-        <p:nvSpPr>
-          <p:cNvPr id="7" name="Shape 5"/>
-          <p:cNvSpPr/>
-          <p:nvPr/>
-        </p:nvSpPr>
-        <p:spPr>
-          <a:xfrm>
-            <a:off x="9720834" y="420624"/>
-            <a:ext cx="0" cy="6053328"/>
-          </a:xfrm>
-          <a:prstGeom prst="line">
-            <a:avLst/>
-          </a:prstGeom>
-          <a:noFill/>
-          <a:ln w="12700">
-            <a:solidFill>
-              <a:srgbClr val="BCCDD8">
-                <a:alpha val="38000"/>
-              </a:srgbClr>
-            </a:solidFill>
-            <a:prstDash val="solid"/>
-          </a:ln>
-        </p:spPr>
-      </p:sp>
-      <p:sp>
-        <p:nvSpPr>
-          <p:cNvPr id="8" name="Shape 6"/>
-          <p:cNvSpPr/>
-          <p:nvPr/>
-        </p:nvSpPr>
-        <p:spPr>
-          <a:xfrm>
-            <a:off x="11533327" y="420624"/>
-            <a:ext cx="0" cy="6053328"/>
-          </a:xfrm>
-          <a:prstGeom prst="line">
-            <a:avLst/>
-          </a:prstGeom>
-          <a:noFill/>
-          <a:ln w="12700">
-            <a:solidFill>
-              <a:srgbClr val="BCCDD8">
-                <a:alpha val="70000"/>
-              </a:srgbClr>
-            </a:solidFill>
-            <a:prstDash val="solid"/>
-          </a:ln>
-        </p:spPr>
-      </p:sp>
-      <p:sp>
-        <p:nvSpPr>
-          <p:cNvPr id="9" name="Shape 7"/>
-          <p:cNvSpPr/>
-          <p:nvPr/>
-        </p:nvSpPr>
-        <p:spPr>
-          <a:xfrm>
-            <a:off x="658368" y="420624"/>
-            <a:ext cx="10874959" cy="0"/>
-          </a:xfrm>
-          <a:prstGeom prst="line">
-            <a:avLst/>
-          </a:prstGeom>
-          <a:noFill/>
-          <a:ln w="12700">
-            <a:solidFill>
-              <a:srgbClr val="BCCDD8">
-                <a:alpha val="32000"/>
-              </a:srgbClr>
-            </a:solidFill>
-            <a:prstDash val="solid"/>
-          </a:ln>
-        </p:spPr>
-      </p:sp>
-      <p:sp>
-        <p:nvSpPr>
-          <p:cNvPr id="10" name="Shape 8"/>
-          <p:cNvSpPr/>
-          <p:nvPr/>
-        </p:nvSpPr>
-        <p:spPr>
-          <a:xfrm>
-            <a:off x="658368" y="1933956"/>
-            <a:ext cx="10874959" cy="0"/>
-          </a:xfrm>
-          <a:prstGeom prst="line">
-            <a:avLst/>
-          </a:prstGeom>
-          <a:noFill/>
-          <a:ln w="12700">
-            <a:solidFill>
-              <a:srgbClr val="BCCDD8">
-                <a:alpha val="32000"/>
-              </a:srgbClr>
-            </a:solidFill>
-            <a:prstDash val="solid"/>
-          </a:ln>
-        </p:spPr>
-      </p:sp>
-      <p:sp>
-        <p:nvSpPr>
-          <p:cNvPr id="11" name="Shape 9"/>
-          <p:cNvSpPr/>
-          <p:nvPr/>
-        </p:nvSpPr>
-        <p:spPr>
-          <a:xfrm>
-            <a:off x="658368" y="3447288"/>
-            <a:ext cx="10874959" cy="0"/>
-          </a:xfrm>
-          <a:prstGeom prst="line">
-            <a:avLst/>
-          </a:prstGeom>
-          <a:noFill/>
-          <a:ln w="12700">
-            <a:solidFill>
-              <a:srgbClr val="BCCDD8">
-                <a:alpha val="32000"/>
-              </a:srgbClr>
-            </a:solidFill>
-            <a:prstDash val="solid"/>
-          </a:ln>
-        </p:spPr>
-      </p:sp>
-      <p:sp>
-        <p:nvSpPr>
-          <p:cNvPr id="12" name="Shape 10"/>
-          <p:cNvSpPr/>
-          <p:nvPr/>
-        </p:nvSpPr>
-        <p:spPr>
-          <a:xfrm>
-            <a:off x="658368" y="4960620"/>
-            <a:ext cx="10874959" cy="0"/>
-          </a:xfrm>
-          <a:prstGeom prst="line">
-            <a:avLst/>
-          </a:prstGeom>
-          <a:noFill/>
-          <a:ln w="12700">
-            <a:solidFill>
-              <a:srgbClr val="BCCDD8">
-                <a:alpha val="32000"/>
-              </a:srgbClr>
-            </a:solidFill>
-            <a:prstDash val="solid"/>
-          </a:ln>
-        </p:spPr>
-      </p:sp>
-      <p:sp>
-        <p:nvSpPr>
-          <p:cNvPr id="13" name="Shape 11"/>
-          <p:cNvSpPr/>
-          <p:nvPr/>
-        </p:nvSpPr>
-        <p:spPr>
-          <a:xfrm>
-            <a:off x="658368" y="6473952"/>
-            <a:ext cx="10874959" cy="0"/>
-          </a:xfrm>
-          <a:prstGeom prst="line">
-            <a:avLst/>
-          </a:prstGeom>
-          <a:noFill/>
-          <a:ln w="12700">
-            <a:solidFill>
-              <a:srgbClr val="BCCDD8">
-                <a:alpha val="32000"/>
-              </a:srgbClr>
-            </a:solidFill>
-            <a:prstDash val="solid"/>
-          </a:ln>
-        </p:spPr>
-      </p:sp>
-      <p:sp>
-        <p:nvSpPr>
-          <p:cNvPr id="14" name="Shape 12"/>
-          <p:cNvSpPr/>
-          <p:nvPr/>
-        </p:nvSpPr>
-        <p:spPr>
-          <a:xfrm>
-            <a:off x="658368" y="420624"/>
-            <a:ext cx="146304" cy="146304"/>
+            <a:off x="658368" y="3154680"/>
+            <a:ext cx="6309360" cy="73152"/>
           </a:xfrm>
           <a:prstGeom prst="rect">
             <a:avLst/>
@@ -1448,63 +1175,9 @@
           </a:ln>
         </p:spPr>
       </p:sp>
-      <p:sp>
-        <p:nvSpPr>
-          <p:cNvPr id="15" name="Shape 13"/>
-          <p:cNvSpPr/>
-          <p:nvPr/>
-        </p:nvSpPr>
-        <p:spPr>
-          <a:xfrm>
-            <a:off x="731520" y="1207008"/>
-            <a:ext cx="1325880" cy="54864"/>
-          </a:xfrm>
-          <a:prstGeom prst="rect">
-            <a:avLst/>
-          </a:prstGeom>
-          <a:solidFill>
-            <a:srgbClr val="9E4C0F"/>
-          </a:solidFill>
-          <a:ln w="12700">
-            <a:solidFill>
-              <a:srgbClr val="9E4C0F">
-                <a:alpha val="0"/>
-              </a:srgbClr>
-            </a:solidFill>
-            <a:prstDash val="solid"/>
-          </a:ln>
-        </p:spPr>
-      </p:sp>
-      <p:sp>
-        <p:nvSpPr>
-          <p:cNvPr id="16" name="Shape 14"/>
-          <p:cNvSpPr/>
-          <p:nvPr/>
-        </p:nvSpPr>
-        <p:spPr>
-          <a:xfrm>
-            <a:off x="658368" y="3154680"/>
-            <a:ext cx="6309360" cy="73152"/>
-          </a:xfrm>
-          <a:prstGeom prst="rect">
-            <a:avLst/>
-          </a:prstGeom>
-          <a:solidFill>
-            <a:srgbClr val="0F766E"/>
-          </a:solidFill>
-          <a:ln w="12700">
-            <a:solidFill>
-              <a:srgbClr val="0F766E">
-                <a:alpha val="0"/>
-              </a:srgbClr>
-            </a:solidFill>
-            <a:prstDash val="solid"/>
-          </a:ln>
-        </p:spPr>
-      </p:sp>
       <p:pic>
         <p:nvPicPr>
-          <p:cNvPr id="17" name="Image 0" descr="preencoded.png">    </p:cNvPr>
+          <p:cNvPr id="4" name="Image 0" descr="preencoded.png">    </p:cNvPr>
           <p:cNvPicPr>
             <a:picLocks noChangeAspect="1"/>
           </p:cNvPicPr>
@@ -1532,9 +1205,45 @@
           </a:prstGeom>
         </p:spPr>
       </p:pic>
+      <p:sp>
+        <p:nvSpPr>
+          <p:cNvPr id="5" name="Shape 2"/>
+          <p:cNvSpPr/>
+          <p:nvPr/>
+        </p:nvSpPr>
+        <p:spPr>
+          <a:xfrm>
+            <a:off x="7333488" y="1060704"/>
+            <a:ext cx="4160520" cy="2011680"/>
+          </a:xfrm>
+          <a:prstGeom prst="rect">
+            <a:avLst/>
+          </a:prstGeom>
+          <a:solidFill>
+            <a:srgbClr val="FBFCFD">
+              <a:alpha val="0"/>
+            </a:srgbClr>
+          </a:solidFill>
+          <a:ln w="12700">
+            <a:solidFill>
+              <a:srgbClr val="D1DFE6">
+                <a:alpha val="0"/>
+              </a:srgbClr>
+            </a:solidFill>
+            <a:prstDash val="solid"/>
+          </a:ln>
+          <a:effectLst>
+            <a:outerShdw sx="100000" sy="100000" kx="0" ky="0" algn="bl" rotWithShape="0" blurRad="12700" dist="50800" dir="2700000">
+              <a:srgbClr val="000000">
+                <a:alpha val="8000"/>
+              </a:srgbClr>
+            </a:outerShdw>
+          </a:effectLst>
+        </p:spPr>
+      </p:sp>
       <p:pic>
         <p:nvPicPr>
-          <p:cNvPr id="18" name="Image 1" descr="preencoded.png">    </p:cNvPr>
+          <p:cNvPr id="6" name="Image 1" descr="preencoded.png">    </p:cNvPr>
           <p:cNvPicPr>
             <a:picLocks noChangeAspect="1"/>
           </p:cNvPicPr>
@@ -1564,7 +1273,43 @@
       </p:pic>
       <p:sp>
         <p:nvSpPr>
-          <p:cNvPr id="19" name="Text 15"/>
+          <p:cNvPr id="7" name="Shape 3"/>
+          <p:cNvSpPr/>
+          <p:nvPr/>
+        </p:nvSpPr>
+        <p:spPr>
+          <a:xfrm>
+            <a:off x="7333488" y="3401568"/>
+            <a:ext cx="4160520" cy="2487168"/>
+          </a:xfrm>
+          <a:prstGeom prst="rect">
+            <a:avLst/>
+          </a:prstGeom>
+          <a:solidFill>
+            <a:srgbClr val="FBFCFD">
+              <a:alpha val="0"/>
+            </a:srgbClr>
+          </a:solidFill>
+          <a:ln w="12700">
+            <a:solidFill>
+              <a:srgbClr val="D1DFE6">
+                <a:alpha val="0"/>
+              </a:srgbClr>
+            </a:solidFill>
+            <a:prstDash val="solid"/>
+          </a:ln>
+          <a:effectLst>
+            <a:outerShdw sx="100000" sy="100000" kx="0" ky="0" algn="bl" rotWithShape="0" blurRad="12700" dist="50800" dir="2700000">
+              <a:srgbClr val="000000">
+                <a:alpha val="8000"/>
+              </a:srgbClr>
+            </a:outerShdw>
+          </a:effectLst>
+        </p:spPr>
+      </p:sp>
+      <p:sp>
+        <p:nvSpPr>
+          <p:cNvPr id="8" name="Text 4"/>
           <p:cNvSpPr txBox="1"/>
           <p:nvPr/>
         </p:nvSpPr>
@@ -1606,7 +1351,7 @@
       </p:sp>
       <p:sp>
         <p:nvSpPr>
-          <p:cNvPr id="20" name="Shape 16"/>
+          <p:cNvPr id="9" name="Shape 5"/>
           <p:cNvSpPr/>
           <p:nvPr/>
         </p:nvSpPr>
@@ -1630,7 +1375,7 @@
       </p:sp>
       <p:sp>
         <p:nvSpPr>
-          <p:cNvPr id="21" name="Shape 17"/>
+          <p:cNvPr id="10" name="Shape 6"/>
           <p:cNvSpPr/>
           <p:nvPr/>
         </p:nvSpPr>
@@ -1654,7 +1399,7 @@
       </p:sp>
       <p:sp>
         <p:nvSpPr>
-          <p:cNvPr id="22" name="Shape 18"/>
+          <p:cNvPr id="11" name="Shape 7"/>
           <p:cNvSpPr/>
           <p:nvPr/>
         </p:nvSpPr>
@@ -1678,7 +1423,7 @@
       </p:sp>
       <p:sp>
         <p:nvSpPr>
-          <p:cNvPr id="23" name="Shape 19"/>
+          <p:cNvPr id="12" name="Shape 8"/>
           <p:cNvSpPr/>
           <p:nvPr/>
         </p:nvSpPr>
@@ -1702,7 +1447,7 @@
       </p:sp>
       <p:sp>
         <p:nvSpPr>
-          <p:cNvPr id="24" name="Shape 20"/>
+          <p:cNvPr id="13" name="Shape 9"/>
           <p:cNvSpPr/>
           <p:nvPr/>
         </p:nvSpPr>
@@ -1736,7 +1481,7 @@
       </p:sp>
       <p:sp>
         <p:nvSpPr>
-          <p:cNvPr id="25" name="Shape 21"/>
+          <p:cNvPr id="14" name="Shape 10"/>
           <p:cNvSpPr/>
           <p:nvPr/>
         </p:nvSpPr>
@@ -1763,7 +1508,7 @@
       </p:sp>
       <p:sp>
         <p:nvSpPr>
-          <p:cNvPr id="26" name="Shape 22"/>
+          <p:cNvPr id="15" name="Shape 11"/>
           <p:cNvSpPr/>
           <p:nvPr/>
         </p:nvSpPr>
@@ -1790,7 +1535,7 @@
       </p:sp>
       <p:sp>
         <p:nvSpPr>
-          <p:cNvPr id="27" name="Text 23"/>
+          <p:cNvPr id="16" name="Text 12"/>
           <p:cNvSpPr txBox="1"/>
           <p:nvPr/>
         </p:nvSpPr>
@@ -1834,7 +1579,7 @@
       </p:sp>
       <p:sp>
         <p:nvSpPr>
-          <p:cNvPr id="28" name="Text 24"/>
+          <p:cNvPr id="17" name="Text 13"/>
           <p:cNvSpPr txBox="1"/>
           <p:nvPr/>
         </p:nvSpPr>
@@ -1878,7 +1623,7 @@
       </p:sp>
       <p:sp>
         <p:nvSpPr>
-          <p:cNvPr id="29" name="Shape 25"/>
+          <p:cNvPr id="18" name="Shape 14"/>
           <p:cNvSpPr/>
           <p:nvPr/>
         </p:nvSpPr>
@@ -1912,7 +1657,7 @@
       </p:sp>
       <p:sp>
         <p:nvSpPr>
-          <p:cNvPr id="30" name="Shape 26"/>
+          <p:cNvPr id="19" name="Shape 15"/>
           <p:cNvSpPr/>
           <p:nvPr/>
         </p:nvSpPr>
@@ -1939,7 +1684,7 @@
       </p:sp>
       <p:sp>
         <p:nvSpPr>
-          <p:cNvPr id="31" name="Shape 27"/>
+          <p:cNvPr id="20" name="Shape 16"/>
           <p:cNvSpPr/>
           <p:nvPr/>
         </p:nvSpPr>
@@ -1966,7 +1711,7 @@
       </p:sp>
       <p:sp>
         <p:nvSpPr>
-          <p:cNvPr id="32" name="Text 28"/>
+          <p:cNvPr id="21" name="Text 17"/>
           <p:cNvSpPr txBox="1"/>
           <p:nvPr/>
         </p:nvSpPr>
@@ -2010,7 +1755,7 @@
       </p:sp>
       <p:sp>
         <p:nvSpPr>
-          <p:cNvPr id="33" name="Text 29"/>
+          <p:cNvPr id="22" name="Text 18"/>
           <p:cNvSpPr txBox="1"/>
           <p:nvPr/>
         </p:nvSpPr>
@@ -2054,7 +1799,7 @@
       </p:sp>
       <p:sp>
         <p:nvSpPr>
-          <p:cNvPr id="34" name="Shape 30"/>
+          <p:cNvPr id="23" name="Shape 19"/>
           <p:cNvSpPr/>
           <p:nvPr/>
         </p:nvSpPr>
@@ -2088,7 +1833,7 @@
       </p:sp>
       <p:sp>
         <p:nvSpPr>
-          <p:cNvPr id="35" name="Shape 31"/>
+          <p:cNvPr id="24" name="Shape 20"/>
           <p:cNvSpPr/>
           <p:nvPr/>
         </p:nvSpPr>
@@ -2115,7 +1860,7 @@
       </p:sp>
       <p:sp>
         <p:nvSpPr>
-          <p:cNvPr id="36" name="Shape 32"/>
+          <p:cNvPr id="25" name="Shape 21"/>
           <p:cNvSpPr/>
           <p:nvPr/>
         </p:nvSpPr>
@@ -2142,7 +1887,7 @@
       </p:sp>
       <p:sp>
         <p:nvSpPr>
-          <p:cNvPr id="37" name="Text 33"/>
+          <p:cNvPr id="26" name="Text 22"/>
           <p:cNvSpPr txBox="1"/>
           <p:nvPr/>
         </p:nvSpPr>
@@ -2186,7 +1931,7 @@
       </p:sp>
       <p:sp>
         <p:nvSpPr>
-          <p:cNvPr id="38" name="Text 34"/>
+          <p:cNvPr id="27" name="Text 23"/>
           <p:cNvSpPr txBox="1"/>
           <p:nvPr/>
         </p:nvSpPr>
@@ -2230,7 +1975,7 @@
       </p:sp>
       <p:sp>
         <p:nvSpPr>
-          <p:cNvPr id="39" name="Shape 35"/>
+          <p:cNvPr id="28" name="Shape 24"/>
           <p:cNvSpPr/>
           <p:nvPr/>
         </p:nvSpPr>
@@ -2264,7 +2009,7 @@
       </p:sp>
       <p:sp>
         <p:nvSpPr>
-          <p:cNvPr id="40" name="Shape 36"/>
+          <p:cNvPr id="29" name="Shape 25"/>
           <p:cNvSpPr/>
           <p:nvPr/>
         </p:nvSpPr>
@@ -2291,7 +2036,7 @@
       </p:sp>
       <p:sp>
         <p:nvSpPr>
-          <p:cNvPr id="41" name="Shape 37"/>
+          <p:cNvPr id="30" name="Shape 26"/>
           <p:cNvSpPr/>
           <p:nvPr/>
         </p:nvSpPr>
@@ -2318,7 +2063,7 @@
       </p:sp>
       <p:sp>
         <p:nvSpPr>
-          <p:cNvPr id="42" name="Text 38"/>
+          <p:cNvPr id="31" name="Text 27"/>
           <p:cNvSpPr txBox="1"/>
           <p:nvPr/>
         </p:nvSpPr>
@@ -2362,7 +2107,7 @@
       </p:sp>
       <p:sp>
         <p:nvSpPr>
-          <p:cNvPr id="43" name="Text 39"/>
+          <p:cNvPr id="32" name="Text 28"/>
           <p:cNvSpPr txBox="1"/>
           <p:nvPr/>
         </p:nvSpPr>
@@ -2406,7 +2151,7 @@
       </p:sp>
       <p:sp>
         <p:nvSpPr>
-          <p:cNvPr id="44" name="Shape 40"/>
+          <p:cNvPr id="33" name="Shape 29"/>
           <p:cNvSpPr/>
           <p:nvPr/>
         </p:nvSpPr>
@@ -2440,7 +2185,7 @@
       </p:sp>
       <p:sp>
         <p:nvSpPr>
-          <p:cNvPr id="45" name="Shape 41"/>
+          <p:cNvPr id="34" name="Shape 30"/>
           <p:cNvSpPr/>
           <p:nvPr/>
         </p:nvSpPr>
@@ -2467,7 +2212,7 @@
       </p:sp>
       <p:sp>
         <p:nvSpPr>
-          <p:cNvPr id="46" name="Shape 42"/>
+          <p:cNvPr id="35" name="Shape 31"/>
           <p:cNvSpPr/>
           <p:nvPr/>
         </p:nvSpPr>
@@ -2494,7 +2239,7 @@
       </p:sp>
       <p:sp>
         <p:nvSpPr>
-          <p:cNvPr id="47" name="Text 43"/>
+          <p:cNvPr id="36" name="Text 32"/>
           <p:cNvSpPr txBox="1"/>
           <p:nvPr/>
         </p:nvSpPr>
@@ -2538,7 +2283,7 @@
       </p:sp>
       <p:sp>
         <p:nvSpPr>
-          <p:cNvPr id="48" name="Text 44"/>
+          <p:cNvPr id="37" name="Text 33"/>
           <p:cNvSpPr txBox="1"/>
           <p:nvPr/>
         </p:nvSpPr>
@@ -2582,7 +2327,7 @@
       </p:sp>
       <p:sp>
         <p:nvSpPr>
-          <p:cNvPr id="49" name="Text 45"/>
+          <p:cNvPr id="38" name="Text 34"/>
           <p:cNvSpPr txBox="1"/>
           <p:nvPr/>
         </p:nvSpPr>
@@ -2741,7 +2486,7 @@
       </p:sp>
       <p:graphicFrame>
         <p:nvGraphicFramePr>
-          <p:cNvPr id="50" name="Chart 0" descr=""/>
+          <p:cNvPr id="39" name="Chart 0" descr=""/>
           <p:cNvGraphicFramePr/>
           <p:nvPr/>
         </p:nvGraphicFramePr>
@@ -2811,7 +2556,7 @@
                   <a:tcPr marL="54864" marR="54864" marT="36576" marB="36576" anchor="ctr">
                     <a:lnL w="12700" cap="flat" cmpd="sng" algn="ctr">
                       <a:solidFill>
-                        <a:srgbClr val="BCCDD8"/>
+                        <a:srgbClr val="D1DFE6"/>
                       </a:solidFill>
                       <a:prstDash val="solid"/>
                       <a:round/>
@@ -2820,7 +2565,7 @@
                     </a:lnL>
                     <a:lnR w="12700" cap="flat" cmpd="sng" algn="ctr">
                       <a:solidFill>
-                        <a:srgbClr val="BCCDD8"/>
+                        <a:srgbClr val="D1DFE6"/>
                       </a:solidFill>
                       <a:prstDash val="solid"/>
                       <a:round/>
@@ -2829,7 +2574,7 @@
                     </a:lnR>
                     <a:lnT w="12700" cap="flat" cmpd="sng" algn="ctr">
                       <a:solidFill>
-                        <a:srgbClr val="BCCDD8"/>
+                        <a:srgbClr val="D1DFE6"/>
                       </a:solidFill>
                       <a:prstDash val="solid"/>
                       <a:round/>
@@ -2838,7 +2583,7 @@
                     </a:lnT>
                     <a:lnB w="12700" cap="flat" cmpd="sng" algn="ctr">
                       <a:solidFill>
-                        <a:srgbClr val="BCCDD8"/>
+                        <a:srgbClr val="D1DFE6"/>
                       </a:solidFill>
                       <a:prstDash val="solid"/>
                       <a:round/>
@@ -2879,7 +2624,7 @@
                   <a:tcPr marL="54864" marR="54864" marT="36576" marB="36576" anchor="ctr">
                     <a:lnL w="12700" cap="flat" cmpd="sng" algn="ctr">
                       <a:solidFill>
-                        <a:srgbClr val="BCCDD8"/>
+                        <a:srgbClr val="D1DFE6"/>
                       </a:solidFill>
                       <a:prstDash val="solid"/>
                       <a:round/>
@@ -2888,7 +2633,7 @@
                     </a:lnL>
                     <a:lnR w="12700" cap="flat" cmpd="sng" algn="ctr">
                       <a:solidFill>
-                        <a:srgbClr val="BCCDD8"/>
+                        <a:srgbClr val="D1DFE6"/>
                       </a:solidFill>
                       <a:prstDash val="solid"/>
                       <a:round/>
@@ -2897,7 +2642,7 @@
                     </a:lnR>
                     <a:lnT w="12700" cap="flat" cmpd="sng" algn="ctr">
                       <a:solidFill>
-                        <a:srgbClr val="BCCDD8"/>
+                        <a:srgbClr val="D1DFE6"/>
                       </a:solidFill>
                       <a:prstDash val="solid"/>
                       <a:round/>
@@ -2906,7 +2651,7 @@
                     </a:lnT>
                     <a:lnB w="12700" cap="flat" cmpd="sng" algn="ctr">
                       <a:solidFill>
-                        <a:srgbClr val="BCCDD8"/>
+                        <a:srgbClr val="D1DFE6"/>
                       </a:solidFill>
                       <a:prstDash val="solid"/>
                       <a:round/>
@@ -2949,7 +2694,7 @@
                   <a:tcPr marL="54864" marR="54864" marT="36576" marB="36576" anchor="ctr">
                     <a:lnL w="12700" cap="flat" cmpd="sng" algn="ctr">
                       <a:solidFill>
-                        <a:srgbClr val="BCCDD8"/>
+                        <a:srgbClr val="D1DFE6"/>
                       </a:solidFill>
                       <a:prstDash val="solid"/>
                       <a:round/>
@@ -2958,7 +2703,7 @@
                     </a:lnL>
                     <a:lnR w="12700" cap="flat" cmpd="sng" algn="ctr">
                       <a:solidFill>
-                        <a:srgbClr val="BCCDD8"/>
+                        <a:srgbClr val="D1DFE6"/>
                       </a:solidFill>
                       <a:prstDash val="solid"/>
                       <a:round/>
@@ -2967,7 +2712,7 @@
                     </a:lnR>
                     <a:lnT w="12700" cap="flat" cmpd="sng" algn="ctr">
                       <a:solidFill>
-                        <a:srgbClr val="BCCDD8"/>
+                        <a:srgbClr val="D1DFE6"/>
                       </a:solidFill>
                       <a:prstDash val="solid"/>
                       <a:round/>
@@ -2976,7 +2721,7 @@
                     </a:lnT>
                     <a:lnB w="12700" cap="flat" cmpd="sng" algn="ctr">
                       <a:solidFill>
-                        <a:srgbClr val="BCCDD8"/>
+                        <a:srgbClr val="D1DFE6"/>
                       </a:solidFill>
                       <a:prstDash val="solid"/>
                       <a:round/>
@@ -3014,7 +2759,7 @@
                   <a:tcPr marL="54864" marR="54864" marT="36576" marB="36576" anchor="ctr">
                     <a:lnL w="12700" cap="flat" cmpd="sng" algn="ctr">
                       <a:solidFill>
-                        <a:srgbClr val="BCCDD8"/>
+                        <a:srgbClr val="D1DFE6"/>
                       </a:solidFill>
                       <a:prstDash val="solid"/>
                       <a:round/>
@@ -3023,7 +2768,7 @@
                     </a:lnL>
                     <a:lnR w="12700" cap="flat" cmpd="sng" algn="ctr">
                       <a:solidFill>
-                        <a:srgbClr val="BCCDD8"/>
+                        <a:srgbClr val="D1DFE6"/>
                       </a:solidFill>
                       <a:prstDash val="solid"/>
                       <a:round/>
@@ -3032,7 +2777,7 @@
                     </a:lnR>
                     <a:lnT w="12700" cap="flat" cmpd="sng" algn="ctr">
                       <a:solidFill>
-                        <a:srgbClr val="BCCDD8"/>
+                        <a:srgbClr val="D1DFE6"/>
                       </a:solidFill>
                       <a:prstDash val="solid"/>
                       <a:round/>
@@ -3041,7 +2786,7 @@
                     </a:lnT>
                     <a:lnB w="12700" cap="flat" cmpd="sng" algn="ctr">
                       <a:solidFill>
-                        <a:srgbClr val="BCCDD8"/>
+                        <a:srgbClr val="D1DFE6"/>
                       </a:solidFill>
                       <a:prstDash val="solid"/>
                       <a:round/>

</xml_diff>

<commit_message>
feat(cli): add agent hint contract
</commit_message>
<xml_diff>
--- a/docs/assets/readme-teaser/deck.pptx
+++ b/docs/assets/readme-teaser/deck.pptx
@@ -171,7 +171,7 @@
                 <c:ptCount val="4"/>
                 <c:lvl>
                   <c:pt idx="0">
-                    <c:v>Themes</c:v>
+                    <c:v>Styles</c:v>
                   </c:pt>
                   <c:pt idx="1">
                     <c:v>Patterns</c:v>
@@ -193,7 +193,7 @@
                 <c:formatCode>General</c:formatCode>
                 <c:ptCount val="4"/>
                 <c:pt idx="0">
-                  <c:v>8</c:v>
+                  <c:v>5</c:v>
                 </c:pt>
                 <c:pt idx="1">
                   <c:v>36</c:v>
@@ -2438,7 +2438,7 @@
                 <a:ea typeface="Pretendard" pitchFamily="34" charset="-122"/>
                 <a:cs typeface="Pretendard" pitchFamily="34" charset="-120"/>
               </a:rPr>
-              <a:t>- 8 themes, 36+ patterns, 12 object families, chart/table/diagram/image/icon coverage.</a:t>
+              <a:t>- 5 pruned styles, 36+ patterns, 12 object families, chart/table/diagram/image/icon coverage.</a:t>
             </a:r>
             <a:endParaRPr lang="en-US" sz="1400" dirty="0"/>
           </a:p>

</xml_diff>

<commit_message>
Fix README preview deployment assets
</commit_message>
<xml_diff>
--- a/docs/assets/readme-teaser/deck.pptx
+++ b/docs/assets/readme-teaser/deck.pptx
@@ -193,7 +193,7 @@
                 <c:formatCode>General</c:formatCode>
                 <c:ptCount val="4"/>
                 <c:pt idx="0">
-                  <c:v>5</c:v>
+                  <c:v>9</c:v>
                 </c:pt>
                 <c:pt idx="1">
                   <c:v>36</c:v>
@@ -290,7 +290,7 @@
           <c:spPr>
             <a:ln w="12700" cap="flat">
               <a:solidFill>
-                <a:srgbClr val="D1DFE6"/>
+                <a:srgbClr val="BCCDD8"/>
               </a:solidFill>
               <a:prstDash val="solid"/>
               <a:round/>
@@ -1129,6 +1129,812 @@
         </p:nvSpPr>
         <p:spPr>
           <a:xfrm>
+            <a:off x="594360" y="530352"/>
+            <a:ext cx="0" cy="5797296"/>
+          </a:xfrm>
+          <a:prstGeom prst="line">
+            <a:avLst/>
+          </a:prstGeom>
+          <a:noFill/>
+          <a:ln w="12700">
+            <a:solidFill>
+              <a:srgbClr val="BCCDD8">
+                <a:alpha val="18000"/>
+              </a:srgbClr>
+            </a:solidFill>
+            <a:prstDash val="solid"/>
+          </a:ln>
+        </p:spPr>
+      </p:sp>
+      <p:sp>
+        <p:nvSpPr>
+          <p:cNvPr id="3" name="Shape 1"/>
+          <p:cNvSpPr/>
+          <p:nvPr/>
+        </p:nvSpPr>
+        <p:spPr>
+          <a:xfrm>
+            <a:off x="1161288" y="530352"/>
+            <a:ext cx="0" cy="5797296"/>
+          </a:xfrm>
+          <a:prstGeom prst="line">
+            <a:avLst/>
+          </a:prstGeom>
+          <a:noFill/>
+          <a:ln w="12700">
+            <a:solidFill>
+              <a:srgbClr val="BCCDD8">
+                <a:alpha val="18000"/>
+              </a:srgbClr>
+            </a:solidFill>
+            <a:prstDash val="solid"/>
+          </a:ln>
+        </p:spPr>
+      </p:sp>
+      <p:sp>
+        <p:nvSpPr>
+          <p:cNvPr id="4" name="Shape 2"/>
+          <p:cNvSpPr/>
+          <p:nvPr/>
+        </p:nvSpPr>
+        <p:spPr>
+          <a:xfrm>
+            <a:off x="1728216" y="530352"/>
+            <a:ext cx="0" cy="5797296"/>
+          </a:xfrm>
+          <a:prstGeom prst="line">
+            <a:avLst/>
+          </a:prstGeom>
+          <a:noFill/>
+          <a:ln w="12700">
+            <a:solidFill>
+              <a:srgbClr val="BCCDD8">
+                <a:alpha val="18000"/>
+              </a:srgbClr>
+            </a:solidFill>
+            <a:prstDash val="solid"/>
+          </a:ln>
+        </p:spPr>
+      </p:sp>
+      <p:sp>
+        <p:nvSpPr>
+          <p:cNvPr id="5" name="Shape 3"/>
+          <p:cNvSpPr/>
+          <p:nvPr/>
+        </p:nvSpPr>
+        <p:spPr>
+          <a:xfrm>
+            <a:off x="2295144" y="530352"/>
+            <a:ext cx="0" cy="5797296"/>
+          </a:xfrm>
+          <a:prstGeom prst="line">
+            <a:avLst/>
+          </a:prstGeom>
+          <a:noFill/>
+          <a:ln w="12700">
+            <a:solidFill>
+              <a:srgbClr val="BCCDD8">
+                <a:alpha val="18000"/>
+              </a:srgbClr>
+            </a:solidFill>
+            <a:prstDash val="solid"/>
+          </a:ln>
+        </p:spPr>
+      </p:sp>
+      <p:sp>
+        <p:nvSpPr>
+          <p:cNvPr id="6" name="Shape 4"/>
+          <p:cNvSpPr/>
+          <p:nvPr/>
+        </p:nvSpPr>
+        <p:spPr>
+          <a:xfrm>
+            <a:off x="2862072" y="530352"/>
+            <a:ext cx="0" cy="5797296"/>
+          </a:xfrm>
+          <a:prstGeom prst="line">
+            <a:avLst/>
+          </a:prstGeom>
+          <a:noFill/>
+          <a:ln w="12700">
+            <a:solidFill>
+              <a:srgbClr val="BCCDD8">
+                <a:alpha val="18000"/>
+              </a:srgbClr>
+            </a:solidFill>
+            <a:prstDash val="solid"/>
+          </a:ln>
+        </p:spPr>
+      </p:sp>
+      <p:sp>
+        <p:nvSpPr>
+          <p:cNvPr id="7" name="Shape 5"/>
+          <p:cNvSpPr/>
+          <p:nvPr/>
+        </p:nvSpPr>
+        <p:spPr>
+          <a:xfrm>
+            <a:off x="3429000" y="530352"/>
+            <a:ext cx="0" cy="5797296"/>
+          </a:xfrm>
+          <a:prstGeom prst="line">
+            <a:avLst/>
+          </a:prstGeom>
+          <a:noFill/>
+          <a:ln w="12700">
+            <a:solidFill>
+              <a:srgbClr val="BCCDD8">
+                <a:alpha val="18000"/>
+              </a:srgbClr>
+            </a:solidFill>
+            <a:prstDash val="solid"/>
+          </a:ln>
+        </p:spPr>
+      </p:sp>
+      <p:sp>
+        <p:nvSpPr>
+          <p:cNvPr id="8" name="Shape 6"/>
+          <p:cNvSpPr/>
+          <p:nvPr/>
+        </p:nvSpPr>
+        <p:spPr>
+          <a:xfrm>
+            <a:off x="3995928" y="530352"/>
+            <a:ext cx="0" cy="5797296"/>
+          </a:xfrm>
+          <a:prstGeom prst="line">
+            <a:avLst/>
+          </a:prstGeom>
+          <a:noFill/>
+          <a:ln w="12700">
+            <a:solidFill>
+              <a:srgbClr val="BCCDD8">
+                <a:alpha val="18000"/>
+              </a:srgbClr>
+            </a:solidFill>
+            <a:prstDash val="solid"/>
+          </a:ln>
+        </p:spPr>
+      </p:sp>
+      <p:sp>
+        <p:nvSpPr>
+          <p:cNvPr id="9" name="Shape 7"/>
+          <p:cNvSpPr/>
+          <p:nvPr/>
+        </p:nvSpPr>
+        <p:spPr>
+          <a:xfrm>
+            <a:off x="4562856" y="530352"/>
+            <a:ext cx="0" cy="5797296"/>
+          </a:xfrm>
+          <a:prstGeom prst="line">
+            <a:avLst/>
+          </a:prstGeom>
+          <a:noFill/>
+          <a:ln w="12700">
+            <a:solidFill>
+              <a:srgbClr val="BCCDD8">
+                <a:alpha val="18000"/>
+              </a:srgbClr>
+            </a:solidFill>
+            <a:prstDash val="solid"/>
+          </a:ln>
+        </p:spPr>
+      </p:sp>
+      <p:sp>
+        <p:nvSpPr>
+          <p:cNvPr id="10" name="Shape 8"/>
+          <p:cNvSpPr/>
+          <p:nvPr/>
+        </p:nvSpPr>
+        <p:spPr>
+          <a:xfrm>
+            <a:off x="5129784" y="530352"/>
+            <a:ext cx="0" cy="5797296"/>
+          </a:xfrm>
+          <a:prstGeom prst="line">
+            <a:avLst/>
+          </a:prstGeom>
+          <a:noFill/>
+          <a:ln w="12700">
+            <a:solidFill>
+              <a:srgbClr val="BCCDD8">
+                <a:alpha val="18000"/>
+              </a:srgbClr>
+            </a:solidFill>
+            <a:prstDash val="solid"/>
+          </a:ln>
+        </p:spPr>
+      </p:sp>
+      <p:sp>
+        <p:nvSpPr>
+          <p:cNvPr id="11" name="Shape 9"/>
+          <p:cNvSpPr/>
+          <p:nvPr/>
+        </p:nvSpPr>
+        <p:spPr>
+          <a:xfrm>
+            <a:off x="5696712" y="530352"/>
+            <a:ext cx="0" cy="5797296"/>
+          </a:xfrm>
+          <a:prstGeom prst="line">
+            <a:avLst/>
+          </a:prstGeom>
+          <a:noFill/>
+          <a:ln w="12700">
+            <a:solidFill>
+              <a:srgbClr val="BCCDD8">
+                <a:alpha val="18000"/>
+              </a:srgbClr>
+            </a:solidFill>
+            <a:prstDash val="solid"/>
+          </a:ln>
+        </p:spPr>
+      </p:sp>
+      <p:sp>
+        <p:nvSpPr>
+          <p:cNvPr id="12" name="Shape 10"/>
+          <p:cNvSpPr/>
+          <p:nvPr/>
+        </p:nvSpPr>
+        <p:spPr>
+          <a:xfrm>
+            <a:off x="6263640" y="530352"/>
+            <a:ext cx="0" cy="5797296"/>
+          </a:xfrm>
+          <a:prstGeom prst="line">
+            <a:avLst/>
+          </a:prstGeom>
+          <a:noFill/>
+          <a:ln w="12700">
+            <a:solidFill>
+              <a:srgbClr val="BCCDD8">
+                <a:alpha val="18000"/>
+              </a:srgbClr>
+            </a:solidFill>
+            <a:prstDash val="solid"/>
+          </a:ln>
+        </p:spPr>
+      </p:sp>
+      <p:sp>
+        <p:nvSpPr>
+          <p:cNvPr id="13" name="Shape 11"/>
+          <p:cNvSpPr/>
+          <p:nvPr/>
+        </p:nvSpPr>
+        <p:spPr>
+          <a:xfrm>
+            <a:off x="6830568" y="530352"/>
+            <a:ext cx="0" cy="5797296"/>
+          </a:xfrm>
+          <a:prstGeom prst="line">
+            <a:avLst/>
+          </a:prstGeom>
+          <a:noFill/>
+          <a:ln w="12700">
+            <a:solidFill>
+              <a:srgbClr val="BCCDD8">
+                <a:alpha val="18000"/>
+              </a:srgbClr>
+            </a:solidFill>
+            <a:prstDash val="solid"/>
+          </a:ln>
+        </p:spPr>
+      </p:sp>
+      <p:sp>
+        <p:nvSpPr>
+          <p:cNvPr id="14" name="Shape 12"/>
+          <p:cNvSpPr/>
+          <p:nvPr/>
+        </p:nvSpPr>
+        <p:spPr>
+          <a:xfrm>
+            <a:off x="7397496" y="530352"/>
+            <a:ext cx="0" cy="5797296"/>
+          </a:xfrm>
+          <a:prstGeom prst="line">
+            <a:avLst/>
+          </a:prstGeom>
+          <a:noFill/>
+          <a:ln w="12700">
+            <a:solidFill>
+              <a:srgbClr val="BCCDD8">
+                <a:alpha val="18000"/>
+              </a:srgbClr>
+            </a:solidFill>
+            <a:prstDash val="solid"/>
+          </a:ln>
+        </p:spPr>
+      </p:sp>
+      <p:sp>
+        <p:nvSpPr>
+          <p:cNvPr id="15" name="Shape 13"/>
+          <p:cNvSpPr/>
+          <p:nvPr/>
+        </p:nvSpPr>
+        <p:spPr>
+          <a:xfrm>
+            <a:off x="7964424" y="530352"/>
+            <a:ext cx="0" cy="5797296"/>
+          </a:xfrm>
+          <a:prstGeom prst="line">
+            <a:avLst/>
+          </a:prstGeom>
+          <a:noFill/>
+          <a:ln w="12700">
+            <a:solidFill>
+              <a:srgbClr val="BCCDD8">
+                <a:alpha val="18000"/>
+              </a:srgbClr>
+            </a:solidFill>
+            <a:prstDash val="solid"/>
+          </a:ln>
+        </p:spPr>
+      </p:sp>
+      <p:sp>
+        <p:nvSpPr>
+          <p:cNvPr id="16" name="Shape 14"/>
+          <p:cNvSpPr/>
+          <p:nvPr/>
+        </p:nvSpPr>
+        <p:spPr>
+          <a:xfrm>
+            <a:off x="8531352" y="530352"/>
+            <a:ext cx="0" cy="5797296"/>
+          </a:xfrm>
+          <a:prstGeom prst="line">
+            <a:avLst/>
+          </a:prstGeom>
+          <a:noFill/>
+          <a:ln w="12700">
+            <a:solidFill>
+              <a:srgbClr val="BCCDD8">
+                <a:alpha val="18000"/>
+              </a:srgbClr>
+            </a:solidFill>
+            <a:prstDash val="solid"/>
+          </a:ln>
+        </p:spPr>
+      </p:sp>
+      <p:sp>
+        <p:nvSpPr>
+          <p:cNvPr id="17" name="Shape 15"/>
+          <p:cNvSpPr/>
+          <p:nvPr/>
+        </p:nvSpPr>
+        <p:spPr>
+          <a:xfrm>
+            <a:off x="9098280" y="530352"/>
+            <a:ext cx="0" cy="5797296"/>
+          </a:xfrm>
+          <a:prstGeom prst="line">
+            <a:avLst/>
+          </a:prstGeom>
+          <a:noFill/>
+          <a:ln w="12700">
+            <a:solidFill>
+              <a:srgbClr val="BCCDD8">
+                <a:alpha val="18000"/>
+              </a:srgbClr>
+            </a:solidFill>
+            <a:prstDash val="solid"/>
+          </a:ln>
+        </p:spPr>
+      </p:sp>
+      <p:sp>
+        <p:nvSpPr>
+          <p:cNvPr id="18" name="Shape 16"/>
+          <p:cNvSpPr/>
+          <p:nvPr/>
+        </p:nvSpPr>
+        <p:spPr>
+          <a:xfrm>
+            <a:off x="9665208" y="530352"/>
+            <a:ext cx="0" cy="5797296"/>
+          </a:xfrm>
+          <a:prstGeom prst="line">
+            <a:avLst/>
+          </a:prstGeom>
+          <a:noFill/>
+          <a:ln w="12700">
+            <a:solidFill>
+              <a:srgbClr val="BCCDD8">
+                <a:alpha val="18000"/>
+              </a:srgbClr>
+            </a:solidFill>
+            <a:prstDash val="solid"/>
+          </a:ln>
+        </p:spPr>
+      </p:sp>
+      <p:sp>
+        <p:nvSpPr>
+          <p:cNvPr id="19" name="Shape 17"/>
+          <p:cNvSpPr/>
+          <p:nvPr/>
+        </p:nvSpPr>
+        <p:spPr>
+          <a:xfrm>
+            <a:off x="10232136" y="530352"/>
+            <a:ext cx="0" cy="5797296"/>
+          </a:xfrm>
+          <a:prstGeom prst="line">
+            <a:avLst/>
+          </a:prstGeom>
+          <a:noFill/>
+          <a:ln w="12700">
+            <a:solidFill>
+              <a:srgbClr val="BCCDD8">
+                <a:alpha val="18000"/>
+              </a:srgbClr>
+            </a:solidFill>
+            <a:prstDash val="solid"/>
+          </a:ln>
+        </p:spPr>
+      </p:sp>
+      <p:sp>
+        <p:nvSpPr>
+          <p:cNvPr id="20" name="Shape 18"/>
+          <p:cNvSpPr/>
+          <p:nvPr/>
+        </p:nvSpPr>
+        <p:spPr>
+          <a:xfrm>
+            <a:off x="10799064" y="530352"/>
+            <a:ext cx="0" cy="5797296"/>
+          </a:xfrm>
+          <a:prstGeom prst="line">
+            <a:avLst/>
+          </a:prstGeom>
+          <a:noFill/>
+          <a:ln w="12700">
+            <a:solidFill>
+              <a:srgbClr val="BCCDD8">
+                <a:alpha val="18000"/>
+              </a:srgbClr>
+            </a:solidFill>
+            <a:prstDash val="solid"/>
+          </a:ln>
+        </p:spPr>
+      </p:sp>
+      <p:sp>
+        <p:nvSpPr>
+          <p:cNvPr id="21" name="Shape 19"/>
+          <p:cNvSpPr/>
+          <p:nvPr/>
+        </p:nvSpPr>
+        <p:spPr>
+          <a:xfrm>
+            <a:off x="11365992" y="530352"/>
+            <a:ext cx="0" cy="5797296"/>
+          </a:xfrm>
+          <a:prstGeom prst="line">
+            <a:avLst/>
+          </a:prstGeom>
+          <a:noFill/>
+          <a:ln w="12700">
+            <a:solidFill>
+              <a:srgbClr val="BCCDD8">
+                <a:alpha val="18000"/>
+              </a:srgbClr>
+            </a:solidFill>
+            <a:prstDash val="solid"/>
+          </a:ln>
+        </p:spPr>
+      </p:sp>
+      <p:sp>
+        <p:nvSpPr>
+          <p:cNvPr id="22" name="Shape 20"/>
+          <p:cNvSpPr/>
+          <p:nvPr/>
+        </p:nvSpPr>
+        <p:spPr>
+          <a:xfrm>
+            <a:off x="594360" y="530352"/>
+            <a:ext cx="11002975" cy="0"/>
+          </a:xfrm>
+          <a:prstGeom prst="line">
+            <a:avLst/>
+          </a:prstGeom>
+          <a:noFill/>
+          <a:ln w="12700">
+            <a:solidFill>
+              <a:srgbClr val="BCCDD8">
+                <a:alpha val="16000"/>
+              </a:srgbClr>
+            </a:solidFill>
+            <a:prstDash val="solid"/>
+          </a:ln>
+        </p:spPr>
+      </p:sp>
+      <p:sp>
+        <p:nvSpPr>
+          <p:cNvPr id="23" name="Shape 21"/>
+          <p:cNvSpPr/>
+          <p:nvPr/>
+        </p:nvSpPr>
+        <p:spPr>
+          <a:xfrm>
+            <a:off x="594360" y="1097280"/>
+            <a:ext cx="11002975" cy="0"/>
+          </a:xfrm>
+          <a:prstGeom prst="line">
+            <a:avLst/>
+          </a:prstGeom>
+          <a:noFill/>
+          <a:ln w="12700">
+            <a:solidFill>
+              <a:srgbClr val="BCCDD8">
+                <a:alpha val="16000"/>
+              </a:srgbClr>
+            </a:solidFill>
+            <a:prstDash val="solid"/>
+          </a:ln>
+        </p:spPr>
+      </p:sp>
+      <p:sp>
+        <p:nvSpPr>
+          <p:cNvPr id="24" name="Shape 22"/>
+          <p:cNvSpPr/>
+          <p:nvPr/>
+        </p:nvSpPr>
+        <p:spPr>
+          <a:xfrm>
+            <a:off x="594360" y="1664208"/>
+            <a:ext cx="11002975" cy="0"/>
+          </a:xfrm>
+          <a:prstGeom prst="line">
+            <a:avLst/>
+          </a:prstGeom>
+          <a:noFill/>
+          <a:ln w="12700">
+            <a:solidFill>
+              <a:srgbClr val="BCCDD8">
+                <a:alpha val="16000"/>
+              </a:srgbClr>
+            </a:solidFill>
+            <a:prstDash val="solid"/>
+          </a:ln>
+        </p:spPr>
+      </p:sp>
+      <p:sp>
+        <p:nvSpPr>
+          <p:cNvPr id="25" name="Shape 23"/>
+          <p:cNvSpPr/>
+          <p:nvPr/>
+        </p:nvSpPr>
+        <p:spPr>
+          <a:xfrm>
+            <a:off x="594360" y="2231136"/>
+            <a:ext cx="11002975" cy="0"/>
+          </a:xfrm>
+          <a:prstGeom prst="line">
+            <a:avLst/>
+          </a:prstGeom>
+          <a:noFill/>
+          <a:ln w="12700">
+            <a:solidFill>
+              <a:srgbClr val="BCCDD8">
+                <a:alpha val="16000"/>
+              </a:srgbClr>
+            </a:solidFill>
+            <a:prstDash val="solid"/>
+          </a:ln>
+        </p:spPr>
+      </p:sp>
+      <p:sp>
+        <p:nvSpPr>
+          <p:cNvPr id="26" name="Shape 24"/>
+          <p:cNvSpPr/>
+          <p:nvPr/>
+        </p:nvSpPr>
+        <p:spPr>
+          <a:xfrm>
+            <a:off x="594360" y="2798064"/>
+            <a:ext cx="11002975" cy="0"/>
+          </a:xfrm>
+          <a:prstGeom prst="line">
+            <a:avLst/>
+          </a:prstGeom>
+          <a:noFill/>
+          <a:ln w="12700">
+            <a:solidFill>
+              <a:srgbClr val="BCCDD8">
+                <a:alpha val="16000"/>
+              </a:srgbClr>
+            </a:solidFill>
+            <a:prstDash val="solid"/>
+          </a:ln>
+        </p:spPr>
+      </p:sp>
+      <p:sp>
+        <p:nvSpPr>
+          <p:cNvPr id="27" name="Shape 25"/>
+          <p:cNvSpPr/>
+          <p:nvPr/>
+        </p:nvSpPr>
+        <p:spPr>
+          <a:xfrm>
+            <a:off x="594360" y="3364992"/>
+            <a:ext cx="11002975" cy="0"/>
+          </a:xfrm>
+          <a:prstGeom prst="line">
+            <a:avLst/>
+          </a:prstGeom>
+          <a:noFill/>
+          <a:ln w="12700">
+            <a:solidFill>
+              <a:srgbClr val="BCCDD8">
+                <a:alpha val="16000"/>
+              </a:srgbClr>
+            </a:solidFill>
+            <a:prstDash val="solid"/>
+          </a:ln>
+        </p:spPr>
+      </p:sp>
+      <p:sp>
+        <p:nvSpPr>
+          <p:cNvPr id="28" name="Shape 26"/>
+          <p:cNvSpPr/>
+          <p:nvPr/>
+        </p:nvSpPr>
+        <p:spPr>
+          <a:xfrm>
+            <a:off x="594360" y="3931920"/>
+            <a:ext cx="11002975" cy="0"/>
+          </a:xfrm>
+          <a:prstGeom prst="line">
+            <a:avLst/>
+          </a:prstGeom>
+          <a:noFill/>
+          <a:ln w="12700">
+            <a:solidFill>
+              <a:srgbClr val="BCCDD8">
+                <a:alpha val="16000"/>
+              </a:srgbClr>
+            </a:solidFill>
+            <a:prstDash val="solid"/>
+          </a:ln>
+        </p:spPr>
+      </p:sp>
+      <p:sp>
+        <p:nvSpPr>
+          <p:cNvPr id="29" name="Shape 27"/>
+          <p:cNvSpPr/>
+          <p:nvPr/>
+        </p:nvSpPr>
+        <p:spPr>
+          <a:xfrm>
+            <a:off x="594360" y="4498848"/>
+            <a:ext cx="11002975" cy="0"/>
+          </a:xfrm>
+          <a:prstGeom prst="line">
+            <a:avLst/>
+          </a:prstGeom>
+          <a:noFill/>
+          <a:ln w="12700">
+            <a:solidFill>
+              <a:srgbClr val="BCCDD8">
+                <a:alpha val="16000"/>
+              </a:srgbClr>
+            </a:solidFill>
+            <a:prstDash val="solid"/>
+          </a:ln>
+        </p:spPr>
+      </p:sp>
+      <p:sp>
+        <p:nvSpPr>
+          <p:cNvPr id="30" name="Shape 28"/>
+          <p:cNvSpPr/>
+          <p:nvPr/>
+        </p:nvSpPr>
+        <p:spPr>
+          <a:xfrm>
+            <a:off x="594360" y="5065776"/>
+            <a:ext cx="11002975" cy="0"/>
+          </a:xfrm>
+          <a:prstGeom prst="line">
+            <a:avLst/>
+          </a:prstGeom>
+          <a:noFill/>
+          <a:ln w="12700">
+            <a:solidFill>
+              <a:srgbClr val="BCCDD8">
+                <a:alpha val="16000"/>
+              </a:srgbClr>
+            </a:solidFill>
+            <a:prstDash val="solid"/>
+          </a:ln>
+        </p:spPr>
+      </p:sp>
+      <p:sp>
+        <p:nvSpPr>
+          <p:cNvPr id="31" name="Shape 29"/>
+          <p:cNvSpPr/>
+          <p:nvPr/>
+        </p:nvSpPr>
+        <p:spPr>
+          <a:xfrm>
+            <a:off x="594360" y="5632704"/>
+            <a:ext cx="11002975" cy="0"/>
+          </a:xfrm>
+          <a:prstGeom prst="line">
+            <a:avLst/>
+          </a:prstGeom>
+          <a:noFill/>
+          <a:ln w="12700">
+            <a:solidFill>
+              <a:srgbClr val="BCCDD8">
+                <a:alpha val="16000"/>
+              </a:srgbClr>
+            </a:solidFill>
+            <a:prstDash val="solid"/>
+          </a:ln>
+        </p:spPr>
+      </p:sp>
+      <p:sp>
+        <p:nvSpPr>
+          <p:cNvPr id="32" name="Shape 30"/>
+          <p:cNvSpPr/>
+          <p:nvPr/>
+        </p:nvSpPr>
+        <p:spPr>
+          <a:xfrm>
+            <a:off x="594360" y="6199632"/>
+            <a:ext cx="11002975" cy="0"/>
+          </a:xfrm>
+          <a:prstGeom prst="line">
+            <a:avLst/>
+          </a:prstGeom>
+          <a:noFill/>
+          <a:ln w="12700">
+            <a:solidFill>
+              <a:srgbClr val="BCCDD8">
+                <a:alpha val="16000"/>
+              </a:srgbClr>
+            </a:solidFill>
+            <a:prstDash val="solid"/>
+          </a:ln>
+        </p:spPr>
+      </p:sp>
+      <p:sp>
+        <p:nvSpPr>
+          <p:cNvPr id="33" name="Shape 31"/>
+          <p:cNvSpPr/>
+          <p:nvPr/>
+        </p:nvSpPr>
+        <p:spPr>
+          <a:xfrm>
+            <a:off x="10600639" y="457200"/>
+            <a:ext cx="914400" cy="256032"/>
+          </a:xfrm>
+          <a:prstGeom prst="roundRect">
+            <a:avLst>
+              <a:gd name="adj" fmla="val 14286"/>
+            </a:avLst>
+          </a:prstGeom>
+          <a:solidFill>
+            <a:srgbClr val="0F766E">
+              <a:alpha val="92000"/>
+            </a:srgbClr>
+          </a:solidFill>
+          <a:ln w="12700">
+            <a:solidFill>
+              <a:srgbClr val="0F766E">
+                <a:alpha val="0"/>
+              </a:srgbClr>
+            </a:solidFill>
+            <a:prstDash val="solid"/>
+          </a:ln>
+        </p:spPr>
+      </p:sp>
+      <p:sp>
+        <p:nvSpPr>
+          <p:cNvPr id="34" name="Shape 32"/>
+          <p:cNvSpPr/>
+          <p:nvPr/>
+        </p:nvSpPr>
+        <p:spPr>
+          <a:xfrm>
             <a:off x="731520" y="1207008"/>
             <a:ext cx="1325880" cy="54864"/>
           </a:xfrm>
@@ -1148,36 +1954,9 @@
           </a:ln>
         </p:spPr>
       </p:sp>
-      <p:sp>
-        <p:nvSpPr>
-          <p:cNvPr id="3" name="Shape 1"/>
-          <p:cNvSpPr/>
-          <p:nvPr/>
-        </p:nvSpPr>
-        <p:spPr>
-          <a:xfrm>
-            <a:off x="658368" y="3154680"/>
-            <a:ext cx="6309360" cy="73152"/>
-          </a:xfrm>
-          <a:prstGeom prst="rect">
-            <a:avLst/>
-          </a:prstGeom>
-          <a:solidFill>
-            <a:srgbClr val="0F766E"/>
-          </a:solidFill>
-          <a:ln w="12700">
-            <a:solidFill>
-              <a:srgbClr val="0F766E">
-                <a:alpha val="0"/>
-              </a:srgbClr>
-            </a:solidFill>
-            <a:prstDash val="solid"/>
-          </a:ln>
-        </p:spPr>
-      </p:sp>
       <p:pic>
         <p:nvPicPr>
-          <p:cNvPr id="4" name="Image 0" descr="preencoded.png">    </p:cNvPr>
+          <p:cNvPr id="35" name="Image 0" descr="preencoded.png">    </p:cNvPr>
           <p:cNvPicPr>
             <a:picLocks noChangeAspect="1"/>
           </p:cNvPicPr>
@@ -1207,7 +1986,7 @@
       </p:pic>
       <p:sp>
         <p:nvSpPr>
-          <p:cNvPr id="5" name="Shape 2"/>
+          <p:cNvPr id="36" name="Shape 33"/>
           <p:cNvSpPr/>
           <p:nvPr/>
         </p:nvSpPr>
@@ -1226,7 +2005,7 @@
           </a:solidFill>
           <a:ln w="12700">
             <a:solidFill>
-              <a:srgbClr val="D1DFE6">
+              <a:srgbClr val="BCCDD8">
                 <a:alpha val="0"/>
               </a:srgbClr>
             </a:solidFill>
@@ -1243,7 +2022,7 @@
       </p:sp>
       <p:pic>
         <p:nvPicPr>
-          <p:cNvPr id="6" name="Image 1" descr="preencoded.png">    </p:cNvPr>
+          <p:cNvPr id="37" name="Image 1" descr="preencoded.png">    </p:cNvPr>
           <p:cNvPicPr>
             <a:picLocks noChangeAspect="1"/>
           </p:cNvPicPr>
@@ -1263,7 +2042,7 @@
         </p:blipFill>
         <p:spPr>
           <a:xfrm>
-            <a:off x="7333488" y="3401568"/>
+            <a:off x="7333488" y="3264408"/>
             <a:ext cx="4160520" cy="2487168"/>
           </a:xfrm>
           <a:prstGeom prst="rect">
@@ -1273,13 +2052,13 @@
       </p:pic>
       <p:sp>
         <p:nvSpPr>
-          <p:cNvPr id="7" name="Shape 3"/>
-          <p:cNvSpPr/>
-          <p:nvPr/>
-        </p:nvSpPr>
-        <p:spPr>
-          <a:xfrm>
-            <a:off x="7333488" y="3401568"/>
+          <p:cNvPr id="38" name="Shape 34"/>
+          <p:cNvSpPr/>
+          <p:nvPr/>
+        </p:nvSpPr>
+        <p:spPr>
+          <a:xfrm>
+            <a:off x="7333488" y="3264408"/>
             <a:ext cx="4160520" cy="2487168"/>
           </a:xfrm>
           <a:prstGeom prst="rect">
@@ -1292,7 +2071,7 @@
           </a:solidFill>
           <a:ln w="12700">
             <a:solidFill>
-              <a:srgbClr val="D1DFE6">
+              <a:srgbClr val="BCCDD8">
                 <a:alpha val="0"/>
               </a:srgbClr>
             </a:solidFill>
@@ -1309,7 +2088,34 @@
       </p:sp>
       <p:sp>
         <p:nvSpPr>
-          <p:cNvPr id="8" name="Text 4"/>
+          <p:cNvPr id="39" name="Shape 35"/>
+          <p:cNvSpPr/>
+          <p:nvPr/>
+        </p:nvSpPr>
+        <p:spPr>
+          <a:xfrm>
+            <a:off x="658368" y="3154680"/>
+            <a:ext cx="6309360" cy="73152"/>
+          </a:xfrm>
+          <a:prstGeom prst="rect">
+            <a:avLst/>
+          </a:prstGeom>
+          <a:solidFill>
+            <a:srgbClr val="0F766E"/>
+          </a:solidFill>
+          <a:ln w="12700">
+            <a:solidFill>
+              <a:srgbClr val="0F766E">
+                <a:alpha val="0"/>
+              </a:srgbClr>
+            </a:solidFill>
+            <a:prstDash val="solid"/>
+          </a:ln>
+        </p:spPr>
+      </p:sp>
+      <p:sp>
+        <p:nvSpPr>
+          <p:cNvPr id="40" name="mdpr:mdpr-markdown-to-editable-pptx-de2396:title:__title:mdpr-markdown-to-editable-pptx-de2396"/>
           <p:cNvSpPr txBox="1"/>
           <p:nvPr/>
         </p:nvSpPr>
@@ -1351,7 +2157,7 @@
       </p:sp>
       <p:sp>
         <p:nvSpPr>
-          <p:cNvPr id="9" name="Shape 5"/>
+          <p:cNvPr id="41" name="Shape 37"/>
           <p:cNvSpPr/>
           <p:nvPr/>
         </p:nvSpPr>
@@ -1375,7 +2181,7 @@
       </p:sp>
       <p:sp>
         <p:nvSpPr>
-          <p:cNvPr id="10" name="Shape 6"/>
+          <p:cNvPr id="42" name="Shape 38"/>
           <p:cNvSpPr/>
           <p:nvPr/>
         </p:nvSpPr>
@@ -1399,7 +2205,7 @@
       </p:sp>
       <p:sp>
         <p:nvSpPr>
-          <p:cNvPr id="11" name="Shape 7"/>
+          <p:cNvPr id="43" name="Shape 39"/>
           <p:cNvSpPr/>
           <p:nvPr/>
         </p:nvSpPr>
@@ -1423,7 +2229,7 @@
       </p:sp>
       <p:sp>
         <p:nvSpPr>
-          <p:cNvPr id="12" name="Shape 8"/>
+          <p:cNvPr id="44" name="Shape 40"/>
           <p:cNvSpPr/>
           <p:nvPr/>
         </p:nvSpPr>
@@ -1447,7 +2253,7 @@
       </p:sp>
       <p:sp>
         <p:nvSpPr>
-          <p:cNvPr id="13" name="Shape 9"/>
+          <p:cNvPr id="45" name="Shape 41"/>
           <p:cNvSpPr/>
           <p:nvPr/>
         </p:nvSpPr>
@@ -1481,7 +2287,7 @@
       </p:sp>
       <p:sp>
         <p:nvSpPr>
-          <p:cNvPr id="14" name="Shape 10"/>
+          <p:cNvPr id="46" name="Shape 42"/>
           <p:cNvSpPr/>
           <p:nvPr/>
         </p:nvSpPr>
@@ -1508,7 +2314,7 @@
       </p:sp>
       <p:sp>
         <p:nvSpPr>
-          <p:cNvPr id="15" name="Shape 11"/>
+          <p:cNvPr id="47" name="Shape 43"/>
           <p:cNvSpPr/>
           <p:nvPr/>
         </p:nvSpPr>
@@ -1535,7 +2341,7 @@
       </p:sp>
       <p:sp>
         <p:nvSpPr>
-          <p:cNvPr id="16" name="Text 12"/>
+          <p:cNvPr id="48" name="Text 44"/>
           <p:cNvSpPr txBox="1"/>
           <p:nvPr/>
         </p:nvSpPr>
@@ -1579,7 +2385,7 @@
       </p:sp>
       <p:sp>
         <p:nvSpPr>
-          <p:cNvPr id="17" name="Text 13"/>
+          <p:cNvPr id="49" name="Text 45"/>
           <p:cNvSpPr txBox="1"/>
           <p:nvPr/>
         </p:nvSpPr>
@@ -1623,7 +2429,7 @@
       </p:sp>
       <p:sp>
         <p:nvSpPr>
-          <p:cNvPr id="18" name="Shape 14"/>
+          <p:cNvPr id="50" name="Shape 46"/>
           <p:cNvSpPr/>
           <p:nvPr/>
         </p:nvSpPr>
@@ -1657,7 +2463,7 @@
       </p:sp>
       <p:sp>
         <p:nvSpPr>
-          <p:cNvPr id="19" name="Shape 15"/>
+          <p:cNvPr id="51" name="Shape 47"/>
           <p:cNvSpPr/>
           <p:nvPr/>
         </p:nvSpPr>
@@ -1684,7 +2490,7 @@
       </p:sp>
       <p:sp>
         <p:nvSpPr>
-          <p:cNvPr id="20" name="Shape 16"/>
+          <p:cNvPr id="52" name="Shape 48"/>
           <p:cNvSpPr/>
           <p:nvPr/>
         </p:nvSpPr>
@@ -1711,7 +2517,7 @@
       </p:sp>
       <p:sp>
         <p:nvSpPr>
-          <p:cNvPr id="21" name="Text 17"/>
+          <p:cNvPr id="53" name="Text 49"/>
           <p:cNvSpPr txBox="1"/>
           <p:nvPr/>
         </p:nvSpPr>
@@ -1755,7 +2561,7 @@
       </p:sp>
       <p:sp>
         <p:nvSpPr>
-          <p:cNvPr id="22" name="Text 18"/>
+          <p:cNvPr id="54" name="Text 50"/>
           <p:cNvSpPr txBox="1"/>
           <p:nvPr/>
         </p:nvSpPr>
@@ -1799,7 +2605,7 @@
       </p:sp>
       <p:sp>
         <p:nvSpPr>
-          <p:cNvPr id="23" name="Shape 19"/>
+          <p:cNvPr id="55" name="Shape 51"/>
           <p:cNvSpPr/>
           <p:nvPr/>
         </p:nvSpPr>
@@ -1833,7 +2639,7 @@
       </p:sp>
       <p:sp>
         <p:nvSpPr>
-          <p:cNvPr id="24" name="Shape 20"/>
+          <p:cNvPr id="56" name="Shape 52"/>
           <p:cNvSpPr/>
           <p:nvPr/>
         </p:nvSpPr>
@@ -1860,7 +2666,7 @@
       </p:sp>
       <p:sp>
         <p:nvSpPr>
-          <p:cNvPr id="25" name="Shape 21"/>
+          <p:cNvPr id="57" name="Shape 53"/>
           <p:cNvSpPr/>
           <p:nvPr/>
         </p:nvSpPr>
@@ -1887,7 +2693,7 @@
       </p:sp>
       <p:sp>
         <p:nvSpPr>
-          <p:cNvPr id="26" name="Text 22"/>
+          <p:cNvPr id="58" name="Text 54"/>
           <p:cNvSpPr txBox="1"/>
           <p:nvPr/>
         </p:nvSpPr>
@@ -1931,7 +2737,7 @@
       </p:sp>
       <p:sp>
         <p:nvSpPr>
-          <p:cNvPr id="27" name="Text 23"/>
+          <p:cNvPr id="59" name="Text 55"/>
           <p:cNvSpPr txBox="1"/>
           <p:nvPr/>
         </p:nvSpPr>
@@ -1975,7 +2781,7 @@
       </p:sp>
       <p:sp>
         <p:nvSpPr>
-          <p:cNvPr id="28" name="Shape 24"/>
+          <p:cNvPr id="60" name="Shape 56"/>
           <p:cNvSpPr/>
           <p:nvPr/>
         </p:nvSpPr>
@@ -2009,7 +2815,7 @@
       </p:sp>
       <p:sp>
         <p:nvSpPr>
-          <p:cNvPr id="29" name="Shape 25"/>
+          <p:cNvPr id="61" name="Shape 57"/>
           <p:cNvSpPr/>
           <p:nvPr/>
         </p:nvSpPr>
@@ -2036,7 +2842,7 @@
       </p:sp>
       <p:sp>
         <p:nvSpPr>
-          <p:cNvPr id="30" name="Shape 26"/>
+          <p:cNvPr id="62" name="Shape 58"/>
           <p:cNvSpPr/>
           <p:nvPr/>
         </p:nvSpPr>
@@ -2063,7 +2869,7 @@
       </p:sp>
       <p:sp>
         <p:nvSpPr>
-          <p:cNvPr id="31" name="Text 27"/>
+          <p:cNvPr id="63" name="Text 59"/>
           <p:cNvSpPr txBox="1"/>
           <p:nvPr/>
         </p:nvSpPr>
@@ -2107,7 +2913,7 @@
       </p:sp>
       <p:sp>
         <p:nvSpPr>
-          <p:cNvPr id="32" name="Text 28"/>
+          <p:cNvPr id="64" name="Text 60"/>
           <p:cNvSpPr txBox="1"/>
           <p:nvPr/>
         </p:nvSpPr>
@@ -2151,7 +2957,7 @@
       </p:sp>
       <p:sp>
         <p:nvSpPr>
-          <p:cNvPr id="33" name="Shape 29"/>
+          <p:cNvPr id="65" name="Shape 61"/>
           <p:cNvSpPr/>
           <p:nvPr/>
         </p:nvSpPr>
@@ -2185,7 +2991,7 @@
       </p:sp>
       <p:sp>
         <p:nvSpPr>
-          <p:cNvPr id="34" name="Shape 30"/>
+          <p:cNvPr id="66" name="Shape 62"/>
           <p:cNvSpPr/>
           <p:nvPr/>
         </p:nvSpPr>
@@ -2212,7 +3018,7 @@
       </p:sp>
       <p:sp>
         <p:nvSpPr>
-          <p:cNvPr id="35" name="Shape 31"/>
+          <p:cNvPr id="67" name="Shape 63"/>
           <p:cNvSpPr/>
           <p:nvPr/>
         </p:nvSpPr>
@@ -2239,7 +3045,7 @@
       </p:sp>
       <p:sp>
         <p:nvSpPr>
-          <p:cNvPr id="36" name="Text 32"/>
+          <p:cNvPr id="68" name="Text 64"/>
           <p:cNvSpPr txBox="1"/>
           <p:nvPr/>
         </p:nvSpPr>
@@ -2283,7 +3089,7 @@
       </p:sp>
       <p:sp>
         <p:nvSpPr>
-          <p:cNvPr id="37" name="Text 33"/>
+          <p:cNvPr id="69" name="Text 65"/>
           <p:cNvSpPr txBox="1"/>
           <p:nvPr/>
         </p:nvSpPr>
@@ -2327,7 +3133,7 @@
       </p:sp>
       <p:sp>
         <p:nvSpPr>
-          <p:cNvPr id="38" name="Text 34"/>
+          <p:cNvPr id="70" name="mdpr:mdpr-markdown-to-editable-pptx-de2396:feature-summary:block-5"/>
           <p:cNvSpPr txBox="1"/>
           <p:nvPr/>
         </p:nvSpPr>
@@ -2438,7 +3244,7 @@
                 <a:ea typeface="Pretendard" pitchFamily="34" charset="-122"/>
                 <a:cs typeface="Pretendard" pitchFamily="34" charset="-120"/>
               </a:rPr>
-              <a:t>- 5 pruned styles, 36+ patterns, 12 object families, chart/table/diagram/image/icon coverage.</a:t>
+              <a:t>- 9 themes, 36+ patterns, 12 object families, chart/table/diagram/image/icon coverage.</a:t>
             </a:r>
             <a:endParaRPr lang="en-US" sz="1400" dirty="0"/>
           </a:p>
@@ -2486,7 +3292,7 @@
       </p:sp>
       <p:graphicFrame>
         <p:nvGraphicFramePr>
-          <p:cNvPr id="39" name="Chart 0" descr=""/>
+          <p:cNvPr id="71" name="Chart 0" descr=""/>
           <p:cNvGraphicFramePr/>
           <p:nvPr/>
         </p:nvGraphicFramePr>
@@ -2502,7 +3308,7 @@
       </p:graphicFrame>
       <p:graphicFrame>
         <p:nvGraphicFramePr>
-          <p:cNvPr id="2" name="Table 0"/>
+          <p:cNvPr id="2" name="mdpr:mdpr-markdown-to-editable-pptx-de2396:table:block-9"/>
           <p:cNvGraphicFramePr>
             <a:graphicFrameLocks noGrp="1"/>
           </p:cNvGraphicFramePr>
@@ -2515,7 +3321,7 @@
           </p:nvPr>
         </p:nvGraphicFramePr>
         <p:xfrm>
-          <a:off x="7333488" y="3401568"/>
+          <a:off x="7333488" y="3264408"/>
           <a:ext cx="4160520" cy="2487168"/>
         </p:xfrm>
         <a:graphic>
@@ -2556,7 +3362,7 @@
                   <a:tcPr marL="54864" marR="54864" marT="36576" marB="36576" anchor="ctr">
                     <a:lnL w="12700" cap="flat" cmpd="sng" algn="ctr">
                       <a:solidFill>
-                        <a:srgbClr val="D1DFE6"/>
+                        <a:srgbClr val="BCCDD8"/>
                       </a:solidFill>
                       <a:prstDash val="solid"/>
                       <a:round/>
@@ -2565,7 +3371,7 @@
                     </a:lnL>
                     <a:lnR w="12700" cap="flat" cmpd="sng" algn="ctr">
                       <a:solidFill>
-                        <a:srgbClr val="D1DFE6"/>
+                        <a:srgbClr val="BCCDD8"/>
                       </a:solidFill>
                       <a:prstDash val="solid"/>
                       <a:round/>
@@ -2574,7 +3380,7 @@
                     </a:lnR>
                     <a:lnT w="12700" cap="flat" cmpd="sng" algn="ctr">
                       <a:solidFill>
-                        <a:srgbClr val="D1DFE6"/>
+                        <a:srgbClr val="BCCDD8"/>
                       </a:solidFill>
                       <a:prstDash val="solid"/>
                       <a:round/>
@@ -2583,7 +3389,7 @@
                     </a:lnT>
                     <a:lnB w="12700" cap="flat" cmpd="sng" algn="ctr">
                       <a:solidFill>
-                        <a:srgbClr val="D1DFE6"/>
+                        <a:srgbClr val="BCCDD8"/>
                       </a:solidFill>
                       <a:prstDash val="solid"/>
                       <a:round/>
@@ -2624,7 +3430,7 @@
                   <a:tcPr marL="54864" marR="54864" marT="36576" marB="36576" anchor="ctr">
                     <a:lnL w="12700" cap="flat" cmpd="sng" algn="ctr">
                       <a:solidFill>
-                        <a:srgbClr val="D1DFE6"/>
+                        <a:srgbClr val="BCCDD8"/>
                       </a:solidFill>
                       <a:prstDash val="solid"/>
                       <a:round/>
@@ -2633,7 +3439,7 @@
                     </a:lnL>
                     <a:lnR w="12700" cap="flat" cmpd="sng" algn="ctr">
                       <a:solidFill>
-                        <a:srgbClr val="D1DFE6"/>
+                        <a:srgbClr val="BCCDD8"/>
                       </a:solidFill>
                       <a:prstDash val="solid"/>
                       <a:round/>
@@ -2642,7 +3448,7 @@
                     </a:lnR>
                     <a:lnT w="12700" cap="flat" cmpd="sng" algn="ctr">
                       <a:solidFill>
-                        <a:srgbClr val="D1DFE6"/>
+                        <a:srgbClr val="BCCDD8"/>
                       </a:solidFill>
                       <a:prstDash val="solid"/>
                       <a:round/>
@@ -2651,7 +3457,7 @@
                     </a:lnT>
                     <a:lnB w="12700" cap="flat" cmpd="sng" algn="ctr">
                       <a:solidFill>
-                        <a:srgbClr val="D1DFE6"/>
+                        <a:srgbClr val="BCCDD8"/>
                       </a:solidFill>
                       <a:prstDash val="solid"/>
                       <a:round/>
@@ -2694,7 +3500,7 @@
                   <a:tcPr marL="54864" marR="54864" marT="36576" marB="36576" anchor="ctr">
                     <a:lnL w="12700" cap="flat" cmpd="sng" algn="ctr">
                       <a:solidFill>
-                        <a:srgbClr val="D1DFE6"/>
+                        <a:srgbClr val="BCCDD8"/>
                       </a:solidFill>
                       <a:prstDash val="solid"/>
                       <a:round/>
@@ -2703,7 +3509,7 @@
                     </a:lnL>
                     <a:lnR w="12700" cap="flat" cmpd="sng" algn="ctr">
                       <a:solidFill>
-                        <a:srgbClr val="D1DFE6"/>
+                        <a:srgbClr val="BCCDD8"/>
                       </a:solidFill>
                       <a:prstDash val="solid"/>
                       <a:round/>
@@ -2712,7 +3518,7 @@
                     </a:lnR>
                     <a:lnT w="12700" cap="flat" cmpd="sng" algn="ctr">
                       <a:solidFill>
-                        <a:srgbClr val="D1DFE6"/>
+                        <a:srgbClr val="BCCDD8"/>
                       </a:solidFill>
                       <a:prstDash val="solid"/>
                       <a:round/>
@@ -2721,7 +3527,7 @@
                     </a:lnT>
                     <a:lnB w="12700" cap="flat" cmpd="sng" algn="ctr">
                       <a:solidFill>
-                        <a:srgbClr val="D1DFE6"/>
+                        <a:srgbClr val="BCCDD8"/>
                       </a:solidFill>
                       <a:prstDash val="solid"/>
                       <a:round/>
@@ -2759,7 +3565,7 @@
                   <a:tcPr marL="54864" marR="54864" marT="36576" marB="36576" anchor="ctr">
                     <a:lnL w="12700" cap="flat" cmpd="sng" algn="ctr">
                       <a:solidFill>
-                        <a:srgbClr val="D1DFE6"/>
+                        <a:srgbClr val="BCCDD8"/>
                       </a:solidFill>
                       <a:prstDash val="solid"/>
                       <a:round/>
@@ -2768,7 +3574,7 @@
                     </a:lnL>
                     <a:lnR w="12700" cap="flat" cmpd="sng" algn="ctr">
                       <a:solidFill>
-                        <a:srgbClr val="D1DFE6"/>
+                        <a:srgbClr val="BCCDD8"/>
                       </a:solidFill>
                       <a:prstDash val="solid"/>
                       <a:round/>
@@ -2777,7 +3583,7 @@
                     </a:lnR>
                     <a:lnT w="12700" cap="flat" cmpd="sng" algn="ctr">
                       <a:solidFill>
-                        <a:srgbClr val="D1DFE6"/>
+                        <a:srgbClr val="BCCDD8"/>
                       </a:solidFill>
                       <a:prstDash val="solid"/>
                       <a:round/>
@@ -2786,7 +3592,7 @@
                     </a:lnT>
                     <a:lnB w="12700" cap="flat" cmpd="sng" algn="ctr">
                       <a:solidFill>
-                        <a:srgbClr val="D1DFE6"/>
+                        <a:srgbClr val="BCCDD8"/>
                       </a:solidFill>
                       <a:prstDash val="solid"/>
                       <a:round/>

</xml_diff>

<commit_message>
Normalize theme text luminance
</commit_message>
<xml_diff>
--- a/docs/assets/readme-teaser/deck.pptx
+++ b/docs/assets/readme-teaser/deck.pptx
@@ -265,7 +265,7 @@
             <a:pPr>
               <a:defRPr sz="1100" b="0" i="0" u="none" strike="noStrike">
                 <a:solidFill>
-                  <a:srgbClr val="111827"/>
+                  <a:srgbClr val="111111"/>
                 </a:solidFill>
                 <a:latin typeface="Pretendard"/>
               </a:defRPr>
@@ -317,7 +317,7 @@
             <a:pPr>
               <a:defRPr sz="1100" b="0" i="0" u="none" strike="noStrike">
                 <a:solidFill>
-                  <a:srgbClr val="475569"/>
+                  <a:srgbClr val="919191"/>
                 </a:solidFill>
                 <a:latin typeface="Pretendard"/>
               </a:defRPr>
@@ -2143,7 +2143,7 @@
             <a:r>
               <a:rPr lang="en-US" sz="3200" b="1" dirty="0">
                 <a:solidFill>
-                  <a:srgbClr val="111827"/>
+                  <a:srgbClr val="111111"/>
                 </a:solidFill>
                 <a:latin typeface="Pretendard" pitchFamily="34" charset="0"/>
                 <a:ea typeface="Pretendard" pitchFamily="34" charset="-122"/>
@@ -2415,7 +2415,7 @@
             <a:r>
               <a:rPr lang="en-US" sz="1400" dirty="0">
                 <a:solidFill>
-                  <a:srgbClr val="111827"/>
+                  <a:srgbClr val="111111"/>
                 </a:solidFill>
                 <a:latin typeface="Pretendard" pitchFamily="34" charset="0"/>
                 <a:ea typeface="Pretendard" pitchFamily="34" charset="-122"/>
@@ -2591,7 +2591,7 @@
             <a:r>
               <a:rPr lang="en-US" sz="1400" dirty="0">
                 <a:solidFill>
-                  <a:srgbClr val="111827"/>
+                  <a:srgbClr val="111111"/>
                 </a:solidFill>
                 <a:latin typeface="Pretendard" pitchFamily="34" charset="0"/>
                 <a:ea typeface="Pretendard" pitchFamily="34" charset="-122"/>
@@ -2767,7 +2767,7 @@
             <a:r>
               <a:rPr lang="en-US" sz="1400" dirty="0">
                 <a:solidFill>
-                  <a:srgbClr val="111827"/>
+                  <a:srgbClr val="111111"/>
                 </a:solidFill>
                 <a:latin typeface="Pretendard" pitchFamily="34" charset="0"/>
                 <a:ea typeface="Pretendard" pitchFamily="34" charset="-122"/>
@@ -2943,7 +2943,7 @@
             <a:r>
               <a:rPr lang="en-US" sz="1400" dirty="0">
                 <a:solidFill>
-                  <a:srgbClr val="111827"/>
+                  <a:srgbClr val="111111"/>
                 </a:solidFill>
                 <a:latin typeface="Pretendard" pitchFamily="34" charset="0"/>
                 <a:ea typeface="Pretendard" pitchFamily="34" charset="-122"/>
@@ -3119,7 +3119,7 @@
             <a:r>
               <a:rPr lang="en-US" sz="1400" dirty="0">
                 <a:solidFill>
-                  <a:srgbClr val="111827"/>
+                  <a:srgbClr val="111111"/>
                 </a:solidFill>
                 <a:latin typeface="Pretendard" pitchFamily="34" charset="0"/>
                 <a:ea typeface="Pretendard" pitchFamily="34" charset="-122"/>
@@ -3178,7 +3178,7 @@
             <a:r>
               <a:rPr lang="en-US" sz="1400" dirty="0">
                 <a:solidFill>
-                  <a:srgbClr val="111827"/>
+                  <a:srgbClr val="111111"/>
                 </a:solidFill>
                 <a:latin typeface="Pretendard" pitchFamily="34" charset="0"/>
                 <a:ea typeface="Pretendard" pitchFamily="34" charset="-122"/>
@@ -3218,7 +3218,7 @@
             <a:r>
               <a:rPr lang="en-US" sz="1400" dirty="0">
                 <a:solidFill>
-                  <a:srgbClr val="111827"/>
+                  <a:srgbClr val="111111"/>
                 </a:solidFill>
                 <a:latin typeface="Pretendard" pitchFamily="34" charset="0"/>
                 <a:ea typeface="Pretendard" pitchFamily="34" charset="-122"/>
@@ -3238,7 +3238,7 @@
             <a:r>
               <a:rPr lang="en-US" sz="1400" dirty="0">
                 <a:solidFill>
-                  <a:srgbClr val="111827"/>
+                  <a:srgbClr val="111111"/>
                 </a:solidFill>
                 <a:latin typeface="Pretendard" pitchFamily="34" charset="0"/>
                 <a:ea typeface="Pretendard" pitchFamily="34" charset="-122"/>
@@ -3278,7 +3278,7 @@
             <a:r>
               <a:rPr lang="en-US" sz="1400" dirty="0">
                 <a:solidFill>
-                  <a:srgbClr val="111827"/>
+                  <a:srgbClr val="111111"/>
                 </a:solidFill>
                 <a:latin typeface="Pretendard" pitchFamily="34" charset="0"/>
                 <a:ea typeface="Pretendard" pitchFamily="34" charset="-122"/>
@@ -3482,7 +3482,7 @@
                       <a:r>
                         <a:rPr lang="en-US" sz="1500" b="1" dirty="0">
                           <a:solidFill>
-                            <a:srgbClr val="111827"/>
+                            <a:srgbClr val="111111"/>
                           </a:solidFill>
                           <a:latin typeface="Pretendard" pitchFamily="34" charset="0"/>
                           <a:ea typeface="Pretendard" pitchFamily="34" charset="-122"/>
@@ -3547,7 +3547,7 @@
                       <a:r>
                         <a:rPr lang="en-US" sz="1500" dirty="0">
                           <a:solidFill>
-                            <a:srgbClr val="111827"/>
+                            <a:srgbClr val="111111"/>
                           </a:solidFill>
                           <a:latin typeface="Pretendard" pitchFamily="34" charset="0"/>
                           <a:ea typeface="Pretendard" pitchFamily="34" charset="-122"/>
@@ -3619,13 +3619,13 @@
   <a:themeElements>
     <a:clrScheme name="Office">
       <a:dk1>
-        <a:srgbClr val="111827"/>
+        <a:srgbClr val="111111"/>
       </a:dk1>
       <a:lt1>
         <a:srgbClr val="F8FAFC"/>
       </a:lt1>
       <a:dk2>
-        <a:srgbClr val="475569"/>
+        <a:srgbClr val="919191"/>
       </a:dk2>
       <a:lt2>
         <a:srgbClr val="FBFCFD"/>

</xml_diff>

<commit_message>
Add CHI-style pipeline teaser rules
</commit_message>
<xml_diff>
--- a/docs/assets/readme-teaser/deck.pptx
+++ b/docs/assets/readme-teaser/deck.pptx
@@ -1976,8 +1976,8 @@
         </p:blipFill>
         <p:spPr>
           <a:xfrm>
-            <a:off x="7333488" y="1060704"/>
-            <a:ext cx="4160520" cy="2011680"/>
+            <a:off x="7543800" y="1024128"/>
+            <a:ext cx="4041648" cy="1700784"/>
           </a:xfrm>
           <a:prstGeom prst="rect">
             <a:avLst/>
@@ -1992,8 +1992,8 @@
         </p:nvSpPr>
         <p:spPr>
           <a:xfrm>
-            <a:off x="7333488" y="1060704"/>
-            <a:ext cx="4160520" cy="2011680"/>
+            <a:off x="7543800" y="1024128"/>
+            <a:ext cx="4041648" cy="1700784"/>
           </a:xfrm>
           <a:prstGeom prst="rect">
             <a:avLst/>
@@ -2042,8 +2042,8 @@
         </p:blipFill>
         <p:spPr>
           <a:xfrm>
-            <a:off x="7333488" y="3264408"/>
-            <a:ext cx="4160520" cy="2487168"/>
+            <a:off x="7543800" y="2980944"/>
+            <a:ext cx="4041648" cy="2487168"/>
           </a:xfrm>
           <a:prstGeom prst="rect">
             <a:avLst/>
@@ -2058,8 +2058,8 @@
         </p:nvSpPr>
         <p:spPr>
           <a:xfrm>
-            <a:off x="7333488" y="3264408"/>
-            <a:ext cx="4160520" cy="2487168"/>
+            <a:off x="7543800" y="2980944"/>
+            <a:ext cx="4041648" cy="2487168"/>
           </a:xfrm>
           <a:prstGeom prst="rect">
             <a:avLst/>
@@ -2094,8 +2094,8 @@
         </p:nvSpPr>
         <p:spPr>
           <a:xfrm>
-            <a:off x="658368" y="3154680"/>
-            <a:ext cx="6309360" cy="73152"/>
+            <a:off x="566928" y="3529584"/>
+            <a:ext cx="6784848" cy="73152"/>
           </a:xfrm>
           <a:prstGeom prst="rect">
             <a:avLst/>
@@ -2163,8 +2163,8 @@
         </p:nvSpPr>
         <p:spPr>
           <a:xfrm>
-            <a:off x="2506828" y="1472184"/>
-            <a:ext cx="405689" cy="0"/>
+            <a:off x="2569921" y="1513332"/>
+            <a:ext cx="413614" cy="0"/>
           </a:xfrm>
           <a:prstGeom prst="line">
             <a:avLst/>
@@ -2187,8 +2187,8 @@
         </p:nvSpPr>
         <p:spPr>
           <a:xfrm>
-            <a:off x="4713580" y="1472184"/>
-            <a:ext cx="405689" cy="0"/>
+            <a:off x="4935169" y="1513332"/>
+            <a:ext cx="413614" cy="0"/>
           </a:xfrm>
           <a:prstGeom prst="line">
             <a:avLst/>
@@ -2211,8 +2211,8 @@
         </p:nvSpPr>
         <p:spPr>
           <a:xfrm>
-            <a:off x="6019800" y="1846631"/>
-            <a:ext cx="0" cy="384962"/>
+            <a:off x="6324600" y="1958508"/>
+            <a:ext cx="0" cy="398953"/>
           </a:xfrm>
           <a:prstGeom prst="line">
             <a:avLst/>
@@ -2235,8 +2235,8 @@
         </p:nvSpPr>
         <p:spPr>
           <a:xfrm>
-            <a:off x="4713580" y="2606040"/>
-            <a:ext cx="405689" cy="0"/>
+            <a:off x="4935169" y="2802636"/>
+            <a:ext cx="413614" cy="0"/>
           </a:xfrm>
           <a:prstGeom prst="line">
             <a:avLst/>
@@ -2259,12 +2259,12 @@
         </p:nvSpPr>
         <p:spPr>
           <a:xfrm>
-            <a:off x="658368" y="1060704"/>
-            <a:ext cx="1895856" cy="822960"/>
+            <a:off x="566928" y="1024128"/>
+            <a:ext cx="2054352" cy="978408"/>
           </a:xfrm>
           <a:prstGeom prst="roundRect">
             <a:avLst>
-              <a:gd name="adj" fmla="val 6667"/>
+              <a:gd name="adj" fmla="val 5607"/>
             </a:avLst>
           </a:prstGeom>
           <a:solidFill>
@@ -2293,8 +2293,8 @@
         </p:nvSpPr>
         <p:spPr>
           <a:xfrm>
-            <a:off x="658368" y="1060704"/>
-            <a:ext cx="1895856" cy="109728"/>
+            <a:off x="566928" y="1024128"/>
+            <a:ext cx="2054352" cy="109728"/>
           </a:xfrm>
           <a:prstGeom prst="rect">
             <a:avLst/>
@@ -2320,7 +2320,7 @@
         </p:nvSpPr>
         <p:spPr>
           <a:xfrm>
-            <a:off x="772119" y="1298448"/>
+            <a:off x="690189" y="1339596"/>
             <a:ext cx="347472" cy="347472"/>
           </a:xfrm>
           <a:prstGeom prst="ellipse">
@@ -2347,7 +2347,7 @@
         </p:nvSpPr>
         <p:spPr>
           <a:xfrm>
-            <a:off x="772119" y="1298448"/>
+            <a:off x="690189" y="1339596"/>
             <a:ext cx="347472" cy="347472"/>
           </a:xfrm>
           <a:prstGeom prst="rect">
@@ -2391,8 +2391,8 @@
         </p:nvSpPr>
         <p:spPr>
           <a:xfrm>
-            <a:off x="1265895" y="1188720"/>
-            <a:ext cx="1123737" cy="566928"/>
+            <a:off x="1183965" y="1152144"/>
+            <a:ext cx="1272723" cy="722376"/>
           </a:xfrm>
           <a:prstGeom prst="rect">
             <a:avLst/>
@@ -2413,7 +2413,7 @@
               <a:buNone/>
             </a:pPr>
             <a:r>
-              <a:rPr lang="en-US" sz="1400" dirty="0">
+              <a:rPr lang="en-US" sz="1200" dirty="0">
                 <a:solidFill>
                   <a:srgbClr val="111111"/>
                 </a:solidFill>
@@ -2423,7 +2423,7 @@
               </a:rPr>
               <a:t>Markdown</a:t>
             </a:r>
-            <a:endParaRPr lang="en-US" sz="1400" dirty="0"/>
+            <a:endParaRPr lang="en-US" sz="1200" dirty="0"/>
           </a:p>
         </p:txBody>
       </p:sp>
@@ -2435,12 +2435,12 @@
         </p:nvSpPr>
         <p:spPr>
           <a:xfrm>
-            <a:off x="2865120" y="1060704"/>
-            <a:ext cx="1895856" cy="822960"/>
+            <a:off x="2932176" y="1024128"/>
+            <a:ext cx="2054352" cy="978408"/>
           </a:xfrm>
           <a:prstGeom prst="roundRect">
             <a:avLst>
-              <a:gd name="adj" fmla="val 6667"/>
+              <a:gd name="adj" fmla="val 5607"/>
             </a:avLst>
           </a:prstGeom>
           <a:solidFill>
@@ -2469,8 +2469,8 @@
         </p:nvSpPr>
         <p:spPr>
           <a:xfrm>
-            <a:off x="2865120" y="1060704"/>
-            <a:ext cx="1895856" cy="109728"/>
+            <a:off x="2932176" y="1024128"/>
+            <a:ext cx="2054352" cy="109728"/>
           </a:xfrm>
           <a:prstGeom prst="rect">
             <a:avLst/>
@@ -2496,7 +2496,7 @@
         </p:nvSpPr>
         <p:spPr>
           <a:xfrm>
-            <a:off x="2978871" y="1298448"/>
+            <a:off x="3055437" y="1339596"/>
             <a:ext cx="347472" cy="347472"/>
           </a:xfrm>
           <a:prstGeom prst="ellipse">
@@ -2523,7 +2523,7 @@
         </p:nvSpPr>
         <p:spPr>
           <a:xfrm>
-            <a:off x="2978871" y="1298448"/>
+            <a:off x="3055437" y="1339596"/>
             <a:ext cx="347472" cy="347472"/>
           </a:xfrm>
           <a:prstGeom prst="rect">
@@ -2567,8 +2567,8 @@
         </p:nvSpPr>
         <p:spPr>
           <a:xfrm>
-            <a:off x="3472647" y="1188720"/>
-            <a:ext cx="1123737" cy="566928"/>
+            <a:off x="3549213" y="1152144"/>
+            <a:ext cx="1272723" cy="722376"/>
           </a:xfrm>
           <a:prstGeom prst="rect">
             <a:avLst/>
@@ -2589,7 +2589,7 @@
               <a:buNone/>
             </a:pPr>
             <a:r>
-              <a:rPr lang="en-US" sz="1400" dirty="0">
+              <a:rPr lang="en-US" sz="1200" dirty="0">
                 <a:solidFill>
                   <a:srgbClr val="111111"/>
                 </a:solidFill>
@@ -2599,7 +2599,7 @@
               </a:rPr>
               <a:t>Semantic IR</a:t>
             </a:r>
-            <a:endParaRPr lang="en-US" sz="1400" dirty="0"/>
+            <a:endParaRPr lang="en-US" sz="1200" dirty="0"/>
           </a:p>
         </p:txBody>
       </p:sp>
@@ -2611,12 +2611,12 @@
         </p:nvSpPr>
         <p:spPr>
           <a:xfrm>
-            <a:off x="5071872" y="1060704"/>
-            <a:ext cx="1895856" cy="822960"/>
+            <a:off x="5297424" y="1024128"/>
+            <a:ext cx="2054352" cy="978408"/>
           </a:xfrm>
           <a:prstGeom prst="roundRect">
             <a:avLst>
-              <a:gd name="adj" fmla="val 6667"/>
+              <a:gd name="adj" fmla="val 5607"/>
             </a:avLst>
           </a:prstGeom>
           <a:solidFill>
@@ -2645,8 +2645,8 @@
         </p:nvSpPr>
         <p:spPr>
           <a:xfrm>
-            <a:off x="5071872" y="1060704"/>
-            <a:ext cx="1895856" cy="109728"/>
+            <a:off x="5297424" y="1024128"/>
+            <a:ext cx="2054352" cy="109728"/>
           </a:xfrm>
           <a:prstGeom prst="rect">
             <a:avLst/>
@@ -2672,7 +2672,7 @@
         </p:nvSpPr>
         <p:spPr>
           <a:xfrm>
-            <a:off x="5185623" y="1298448"/>
+            <a:off x="5420685" y="1339596"/>
             <a:ext cx="347472" cy="347472"/>
           </a:xfrm>
           <a:prstGeom prst="ellipse">
@@ -2699,7 +2699,7 @@
         </p:nvSpPr>
         <p:spPr>
           <a:xfrm>
-            <a:off x="5185623" y="1298448"/>
+            <a:off x="5420685" y="1339596"/>
             <a:ext cx="347472" cy="347472"/>
           </a:xfrm>
           <a:prstGeom prst="rect">
@@ -2743,8 +2743,8 @@
         </p:nvSpPr>
         <p:spPr>
           <a:xfrm>
-            <a:off x="5679399" y="1188720"/>
-            <a:ext cx="1123737" cy="566928"/>
+            <a:off x="5914461" y="1152144"/>
+            <a:ext cx="1272723" cy="722376"/>
           </a:xfrm>
           <a:prstGeom prst="rect">
             <a:avLst/>
@@ -2765,7 +2765,7 @@
               <a:buNone/>
             </a:pPr>
             <a:r>
-              <a:rPr lang="en-US" sz="1400" dirty="0">
+              <a:rPr lang="en-US" sz="1200" dirty="0">
                 <a:solidFill>
                   <a:srgbClr val="111111"/>
                 </a:solidFill>
@@ -2775,7 +2775,7 @@
               </a:rPr>
               <a:t>Layout Grammar</a:t>
             </a:r>
-            <a:endParaRPr lang="en-US" sz="1400" dirty="0"/>
+            <a:endParaRPr lang="en-US" sz="1200" dirty="0"/>
           </a:p>
         </p:txBody>
       </p:sp>
@@ -2787,12 +2787,12 @@
         </p:nvSpPr>
         <p:spPr>
           <a:xfrm>
-            <a:off x="5071872" y="2194560"/>
-            <a:ext cx="1895856" cy="822960"/>
+            <a:off x="5297424" y="2313432"/>
+            <a:ext cx="2054352" cy="978408"/>
           </a:xfrm>
           <a:prstGeom prst="roundRect">
             <a:avLst>
-              <a:gd name="adj" fmla="val 6667"/>
+              <a:gd name="adj" fmla="val 5607"/>
             </a:avLst>
           </a:prstGeom>
           <a:solidFill>
@@ -2821,8 +2821,8 @@
         </p:nvSpPr>
         <p:spPr>
           <a:xfrm>
-            <a:off x="5071872" y="2194560"/>
-            <a:ext cx="1895856" cy="109728"/>
+            <a:off x="5297424" y="2313432"/>
+            <a:ext cx="2054352" cy="109728"/>
           </a:xfrm>
           <a:prstGeom prst="rect">
             <a:avLst/>
@@ -2848,7 +2848,7 @@
         </p:nvSpPr>
         <p:spPr>
           <a:xfrm>
-            <a:off x="5185623" y="2432304"/>
+            <a:off x="5420685" y="2628900"/>
             <a:ext cx="347472" cy="347472"/>
           </a:xfrm>
           <a:prstGeom prst="ellipse">
@@ -2875,7 +2875,7 @@
         </p:nvSpPr>
         <p:spPr>
           <a:xfrm>
-            <a:off x="5185623" y="2432304"/>
+            <a:off x="5420685" y="2628900"/>
             <a:ext cx="347472" cy="347472"/>
           </a:xfrm>
           <a:prstGeom prst="rect">
@@ -2919,8 +2919,8 @@
         </p:nvSpPr>
         <p:spPr>
           <a:xfrm>
-            <a:off x="5679399" y="2322576"/>
-            <a:ext cx="1123737" cy="566928"/>
+            <a:off x="5914461" y="2441448"/>
+            <a:ext cx="1272723" cy="722376"/>
           </a:xfrm>
           <a:prstGeom prst="rect">
             <a:avLst/>
@@ -2941,7 +2941,7 @@
               <a:buNone/>
             </a:pPr>
             <a:r>
-              <a:rPr lang="en-US" sz="1400" dirty="0">
+              <a:rPr lang="en-US" sz="1200" dirty="0">
                 <a:solidFill>
                   <a:srgbClr val="111111"/>
                 </a:solidFill>
@@ -2951,7 +2951,7 @@
               </a:rPr>
               <a:t>Theme Tokens</a:t>
             </a:r>
-            <a:endParaRPr lang="en-US" sz="1400" dirty="0"/>
+            <a:endParaRPr lang="en-US" sz="1200" dirty="0"/>
           </a:p>
         </p:txBody>
       </p:sp>
@@ -2963,12 +2963,12 @@
         </p:nvSpPr>
         <p:spPr>
           <a:xfrm>
-            <a:off x="2865120" y="2194560"/>
-            <a:ext cx="1895856" cy="822960"/>
+            <a:off x="2932176" y="2313432"/>
+            <a:ext cx="2054352" cy="978408"/>
           </a:xfrm>
           <a:prstGeom prst="roundRect">
             <a:avLst>
-              <a:gd name="adj" fmla="val 6667"/>
+              <a:gd name="adj" fmla="val 5607"/>
             </a:avLst>
           </a:prstGeom>
           <a:solidFill>
@@ -2997,8 +2997,8 @@
         </p:nvSpPr>
         <p:spPr>
           <a:xfrm>
-            <a:off x="2865120" y="2194560"/>
-            <a:ext cx="1895856" cy="109728"/>
+            <a:off x="2932176" y="2313432"/>
+            <a:ext cx="2054352" cy="109728"/>
           </a:xfrm>
           <a:prstGeom prst="rect">
             <a:avLst/>
@@ -3024,7 +3024,7 @@
         </p:nvSpPr>
         <p:spPr>
           <a:xfrm>
-            <a:off x="2978871" y="2432304"/>
+            <a:off x="3055437" y="2628900"/>
             <a:ext cx="347472" cy="347472"/>
           </a:xfrm>
           <a:prstGeom prst="ellipse">
@@ -3051,7 +3051,7 @@
         </p:nvSpPr>
         <p:spPr>
           <a:xfrm>
-            <a:off x="2978871" y="2432304"/>
+            <a:off x="3055437" y="2628900"/>
             <a:ext cx="347472" cy="347472"/>
           </a:xfrm>
           <a:prstGeom prst="rect">
@@ -3095,8 +3095,8 @@
         </p:nvSpPr>
         <p:spPr>
           <a:xfrm>
-            <a:off x="3472647" y="2322576"/>
-            <a:ext cx="1123737" cy="566928"/>
+            <a:off x="3549213" y="2441448"/>
+            <a:ext cx="1272723" cy="722376"/>
           </a:xfrm>
           <a:prstGeom prst="rect">
             <a:avLst/>
@@ -3117,7 +3117,7 @@
               <a:buNone/>
             </a:pPr>
             <a:r>
-              <a:rPr lang="en-US" sz="1400" dirty="0">
+              <a:rPr lang="en-US" sz="1200" dirty="0">
                 <a:solidFill>
                   <a:srgbClr val="111111"/>
                 </a:solidFill>
@@ -3127,20 +3127,20 @@
               </a:rPr>
               <a:t>Editable PPTX</a:t>
             </a:r>
-            <a:endParaRPr lang="en-US" sz="1400" dirty="0"/>
+            <a:endParaRPr lang="en-US" sz="1200" dirty="0"/>
           </a:p>
         </p:txBody>
       </p:sp>
       <p:sp>
         <p:nvSpPr>
-          <p:cNvPr id="70" name="mdpr:mdpr-markdown-to-editable-pptx-de2396:feature-summary:block-5"/>
+          <p:cNvPr id="70" name="mdpr:mdpr-markdown-to-editable-pptx-de2396:feature-summary:mdpr-markdown-to-editable-pptx-de2396-teaser-overview"/>
           <p:cNvSpPr txBox="1"/>
           <p:nvPr/>
         </p:nvSpPr>
         <p:spPr>
           <a:xfrm>
-            <a:off x="731520" y="3264408"/>
-            <a:ext cx="6163056" cy="2688336"/>
+            <a:off x="640080" y="3639312"/>
+            <a:ext cx="6638544" cy="2286000"/>
           </a:xfrm>
           <a:prstGeom prst="rect">
             <a:avLst/>
@@ -3167,7 +3167,7 @@
                 <a:ea typeface="Pretendard" pitchFamily="34" charset="-122"/>
                 <a:cs typeface="Pretendard" pitchFamily="34" charset="-120"/>
               </a:rPr>
-              <a:t>- PPTX first</a:t>
+              <a:t>- Runtime Pipeline</a:t>
             </a:r>
             <a:pPr algn="l" indent="0" marL="0">
               <a:lnSpc>
@@ -3184,7 +3184,7 @@
                 <a:ea typeface="Pretendard" pitchFamily="34" charset="-122"/>
                 <a:cs typeface="Pretendard" pitchFamily="34" charset="-120"/>
               </a:rPr>
-              <a:t>  editable slides, PNG previews, HTML/PDF exports.</a:t>
+              <a:t>  Markdown -&gt; Semantic IR -&gt; Layout Grammar -&gt; Theme Tokens</a:t>
             </a:r>
             <a:endParaRPr lang="en-US" sz="1400" dirty="0"/>
           </a:p>
@@ -3204,7 +3204,7 @@
                 <a:ea typeface="Pretendard" pitchFamily="34" charset="-122"/>
                 <a:cs typeface="Pretendard" pitchFamily="34" charset="-120"/>
               </a:rPr>
-              <a:t>- No agent runtime</a:t>
+              <a:t>- Main Proof</a:t>
             </a:r>
             <a:endParaRPr lang="en-US" sz="1400" dirty="0"/>
           </a:p>
@@ -3224,7 +3224,27 @@
                 <a:ea typeface="Pretendard" pitchFamily="34" charset="-122"/>
                 <a:cs typeface="Pretendard" pitchFamily="34" charset="-120"/>
               </a:rPr>
-              <a:t>  deterministic parse, split, layout, validation, render.</a:t>
+              <a:t>  PPTX first editable slides, PNG previews, HTML/PDF exports.</a:t>
+            </a:r>
+            <a:endParaRPr lang="en-US" sz="1400" dirty="0"/>
+          </a:p>
+          <a:p>
+            <a:pPr algn="l" indent="0" marL="0">
+              <a:lnSpc>
+                <a:spcPct val="120000"/>
+              </a:lnSpc>
+              <a:buNone/>
+            </a:pPr>
+            <a:r>
+              <a:rPr lang="en-US" sz="1400" b="1" dirty="0">
+                <a:solidFill>
+                  <a:srgbClr val="0F766E"/>
+                </a:solidFill>
+                <a:latin typeface="Pretendard" pitchFamily="34" charset="0"/>
+                <a:ea typeface="Pretendard" pitchFamily="34" charset="-122"/>
+                <a:cs typeface="Pretendard" pitchFamily="34" charset="-120"/>
+              </a:rPr>
+              <a:t>- Coverage</a:t>
             </a:r>
             <a:endParaRPr lang="en-US" sz="1400" dirty="0"/>
           </a:p>
@@ -3244,7 +3264,7 @@
                 <a:ea typeface="Pretendard" pitchFamily="34" charset="-122"/>
                 <a:cs typeface="Pretendard" pitchFamily="34" charset="-120"/>
               </a:rPr>
-              <a:t>- 9 themes, 36+ patterns, 12 object families, chart/table/diagram/image/icon coverage.</a:t>
+              <a:t>  Chart signal: Styles, Patterns, Object families.</a:t>
             </a:r>
             <a:endParaRPr lang="en-US" sz="1400" dirty="0"/>
           </a:p>
@@ -3264,7 +3284,7 @@
                 <a:ea typeface="Pretendard" pitchFamily="34" charset="-122"/>
                 <a:cs typeface="Pretendard" pitchFamily="34" charset="-120"/>
               </a:rPr>
-              <a:t>- Coherence checks</a:t>
+              <a:t>- Boundary</a:t>
             </a:r>
             <a:endParaRPr lang="en-US" sz="1400" dirty="0"/>
           </a:p>
@@ -3284,7 +3304,7 @@
                 <a:ea typeface="Pretendard" pitchFamily="34" charset="-122"/>
                 <a:cs typeface="Pretendard" pitchFamily="34" charset="-120"/>
               </a:rPr>
-              <a:t>  text bounds, graph containment, table fit, PPT theme colors.</a:t>
+              <a:t>  Table proof: MDPR owns / Skill may hint.</a:t>
             </a:r>
             <a:endParaRPr lang="en-US" sz="1400" dirty="0"/>
           </a:p>
@@ -3297,8 +3317,8 @@
           <p:nvPr/>
         </p:nvGraphicFramePr>
         <p:xfrm>
-          <a:off x="7461504" y="1207008"/>
-          <a:ext cx="3904488" cy="1719072"/>
+          <a:off x="7671816" y="1170432"/>
+          <a:ext cx="3785616" cy="1408176"/>
         </p:xfrm>
         <a:graphic xmlns:a="http://schemas.openxmlformats.org/drawingml/2006/main">
           <a:graphicData uri="http://schemas.openxmlformats.org/drawingml/2006/chart">
@@ -3321,16 +3341,16 @@
           </p:nvPr>
         </p:nvGraphicFramePr>
         <p:xfrm>
-          <a:off x="7333488" y="3264408"/>
-          <a:ext cx="4160520" cy="2487168"/>
+          <a:off x="7543800" y="2980944"/>
+          <a:ext cx="4041648" cy="2487168"/>
         </p:xfrm>
         <a:graphic>
           <a:graphicData uri="http://schemas.openxmlformats.org/drawingml/2006/table">
             <a:tbl>
               <a:tblPr/>
               <a:tblGrid>
-                <a:gridCol w="2080260"/>
-                <a:gridCol w="2080260"/>
+                <a:gridCol w="2020824"/>
+                <a:gridCol w="2020824"/>
               </a:tblGrid>
               <a:tr h="1243584">
                 <a:tc>

</xml_diff>

<commit_message>
Optimize theme decoration rules
</commit_message>
<xml_diff>
--- a/docs/assets/readme-teaser/deck.pptx
+++ b/docs/assets/readme-teaser/deck.pptx
@@ -1904,6 +1904,68 @@
         </p:nvSpPr>
         <p:spPr>
           <a:xfrm>
+            <a:off x="658368" y="603504"/>
+            <a:ext cx="1005840" cy="292608"/>
+          </a:xfrm>
+          <a:prstGeom prst="roundRect">
+            <a:avLst>
+              <a:gd name="adj" fmla="val 12500"/>
+            </a:avLst>
+          </a:prstGeom>
+          <a:solidFill>
+            <a:srgbClr val="0F766E">
+              <a:alpha val="28000"/>
+            </a:srgbClr>
+          </a:solidFill>
+          <a:ln w="12700">
+            <a:solidFill>
+              <a:srgbClr val="0F766E">
+                <a:alpha val="0"/>
+              </a:srgbClr>
+            </a:solidFill>
+            <a:prstDash val="solid"/>
+          </a:ln>
+        </p:spPr>
+      </p:sp>
+      <p:sp>
+        <p:nvSpPr>
+          <p:cNvPr id="34" name="Shape 32"/>
+          <p:cNvSpPr/>
+          <p:nvPr/>
+        </p:nvSpPr>
+        <p:spPr>
+          <a:xfrm>
+            <a:off x="9859975" y="5980176"/>
+            <a:ext cx="1591056" cy="292608"/>
+          </a:xfrm>
+          <a:prstGeom prst="roundRect">
+            <a:avLst>
+              <a:gd name="adj" fmla="val 12500"/>
+            </a:avLst>
+          </a:prstGeom>
+          <a:solidFill>
+            <a:srgbClr val="9E0F62">
+              <a:alpha val="18000"/>
+            </a:srgbClr>
+          </a:solidFill>
+          <a:ln w="12700">
+            <a:solidFill>
+              <a:srgbClr val="9E0F62">
+                <a:alpha val="0"/>
+              </a:srgbClr>
+            </a:solidFill>
+            <a:prstDash val="solid"/>
+          </a:ln>
+        </p:spPr>
+      </p:sp>
+      <p:sp>
+        <p:nvSpPr>
+          <p:cNvPr id="35" name="Shape 33"/>
+          <p:cNvSpPr/>
+          <p:nvPr/>
+        </p:nvSpPr>
+        <p:spPr>
+          <a:xfrm>
             <a:off x="10600639" y="457200"/>
             <a:ext cx="914400" cy="256032"/>
           </a:xfrm>
@@ -1929,7 +1991,7 @@
       </p:sp>
       <p:sp>
         <p:nvSpPr>
-          <p:cNvPr id="34" name="Shape 32"/>
+          <p:cNvPr id="36" name="Shape 34"/>
           <p:cNvSpPr/>
           <p:nvPr/>
         </p:nvSpPr>
@@ -1956,7 +2018,7 @@
       </p:sp>
       <p:pic>
         <p:nvPicPr>
-          <p:cNvPr id="35" name="Image 0" descr="preencoded.png">    </p:cNvPr>
+          <p:cNvPr id="37" name="Image 0" descr="preencoded.png">    </p:cNvPr>
           <p:cNvPicPr>
             <a:picLocks noChangeAspect="1"/>
           </p:cNvPicPr>
@@ -1986,7 +2048,7 @@
       </p:pic>
       <p:sp>
         <p:nvSpPr>
-          <p:cNvPr id="36" name="Shape 33"/>
+          <p:cNvPr id="38" name="Shape 35"/>
           <p:cNvSpPr/>
           <p:nvPr/>
         </p:nvSpPr>
@@ -2022,7 +2084,7 @@
       </p:sp>
       <p:pic>
         <p:nvPicPr>
-          <p:cNvPr id="37" name="Image 1" descr="preencoded.png">    </p:cNvPr>
+          <p:cNvPr id="39" name="Image 1" descr="preencoded.png">    </p:cNvPr>
           <p:cNvPicPr>
             <a:picLocks noChangeAspect="1"/>
           </p:cNvPicPr>
@@ -2052,7 +2114,7 @@
       </p:pic>
       <p:sp>
         <p:nvSpPr>
-          <p:cNvPr id="38" name="Shape 34"/>
+          <p:cNvPr id="40" name="Shape 36"/>
           <p:cNvSpPr/>
           <p:nvPr/>
         </p:nvSpPr>
@@ -2088,7 +2150,7 @@
       </p:sp>
       <p:sp>
         <p:nvSpPr>
-          <p:cNvPr id="39" name="Shape 35"/>
+          <p:cNvPr id="41" name="Shape 37"/>
           <p:cNvSpPr/>
           <p:nvPr/>
         </p:nvSpPr>
@@ -2115,7 +2177,7 @@
       </p:sp>
       <p:sp>
         <p:nvSpPr>
-          <p:cNvPr id="40" name="mdpr:mdpr-markdown-to-editable-pptx-de2396:title:__title:mdpr-markdown-to-editable-pptx-de2396"/>
+          <p:cNvPr id="42" name="mdpr:mdpr-markdown-to-editable-pptx-de2396:title:__title:mdpr-markdown-to-editable-pptx-de2396"/>
           <p:cNvSpPr txBox="1"/>
           <p:nvPr/>
         </p:nvSpPr>
@@ -2157,7 +2219,7 @@
       </p:sp>
       <p:sp>
         <p:nvSpPr>
-          <p:cNvPr id="41" name="Shape 37"/>
+          <p:cNvPr id="43" name="Shape 39"/>
           <p:cNvSpPr/>
           <p:nvPr/>
         </p:nvSpPr>
@@ -2181,7 +2243,7 @@
       </p:sp>
       <p:sp>
         <p:nvSpPr>
-          <p:cNvPr id="42" name="Shape 38"/>
+          <p:cNvPr id="44" name="Shape 40"/>
           <p:cNvSpPr/>
           <p:nvPr/>
         </p:nvSpPr>
@@ -2205,7 +2267,7 @@
       </p:sp>
       <p:sp>
         <p:nvSpPr>
-          <p:cNvPr id="43" name="Shape 39"/>
+          <p:cNvPr id="45" name="Shape 41"/>
           <p:cNvSpPr/>
           <p:nvPr/>
         </p:nvSpPr>
@@ -2229,7 +2291,7 @@
       </p:sp>
       <p:sp>
         <p:nvSpPr>
-          <p:cNvPr id="44" name="Shape 40"/>
+          <p:cNvPr id="46" name="Shape 42"/>
           <p:cNvSpPr/>
           <p:nvPr/>
         </p:nvSpPr>
@@ -2253,7 +2315,7 @@
       </p:sp>
       <p:sp>
         <p:nvSpPr>
-          <p:cNvPr id="45" name="Shape 41"/>
+          <p:cNvPr id="47" name="Shape 43"/>
           <p:cNvSpPr/>
           <p:nvPr/>
         </p:nvSpPr>
@@ -2287,7 +2349,7 @@
       </p:sp>
       <p:sp>
         <p:nvSpPr>
-          <p:cNvPr id="46" name="Shape 42"/>
+          <p:cNvPr id="48" name="Shape 44"/>
           <p:cNvSpPr/>
           <p:nvPr/>
         </p:nvSpPr>
@@ -2314,7 +2376,7 @@
       </p:sp>
       <p:sp>
         <p:nvSpPr>
-          <p:cNvPr id="47" name="Shape 43"/>
+          <p:cNvPr id="49" name="Shape 45"/>
           <p:cNvSpPr/>
           <p:nvPr/>
         </p:nvSpPr>
@@ -2341,7 +2403,7 @@
       </p:sp>
       <p:sp>
         <p:nvSpPr>
-          <p:cNvPr id="48" name="Text 44"/>
+          <p:cNvPr id="50" name="Text 46"/>
           <p:cNvSpPr txBox="1"/>
           <p:nvPr/>
         </p:nvSpPr>
@@ -2385,7 +2447,7 @@
       </p:sp>
       <p:sp>
         <p:nvSpPr>
-          <p:cNvPr id="49" name="Text 45"/>
+          <p:cNvPr id="51" name="Text 47"/>
           <p:cNvSpPr txBox="1"/>
           <p:nvPr/>
         </p:nvSpPr>
@@ -2429,7 +2491,7 @@
       </p:sp>
       <p:sp>
         <p:nvSpPr>
-          <p:cNvPr id="50" name="Shape 46"/>
+          <p:cNvPr id="52" name="Shape 48"/>
           <p:cNvSpPr/>
           <p:nvPr/>
         </p:nvSpPr>
@@ -2463,7 +2525,7 @@
       </p:sp>
       <p:sp>
         <p:nvSpPr>
-          <p:cNvPr id="51" name="Shape 47"/>
+          <p:cNvPr id="53" name="Shape 49"/>
           <p:cNvSpPr/>
           <p:nvPr/>
         </p:nvSpPr>
@@ -2490,7 +2552,7 @@
       </p:sp>
       <p:sp>
         <p:nvSpPr>
-          <p:cNvPr id="52" name="Shape 48"/>
+          <p:cNvPr id="54" name="Shape 50"/>
           <p:cNvSpPr/>
           <p:nvPr/>
         </p:nvSpPr>
@@ -2517,7 +2579,7 @@
       </p:sp>
       <p:sp>
         <p:nvSpPr>
-          <p:cNvPr id="53" name="Text 49"/>
+          <p:cNvPr id="55" name="Text 51"/>
           <p:cNvSpPr txBox="1"/>
           <p:nvPr/>
         </p:nvSpPr>
@@ -2561,7 +2623,7 @@
       </p:sp>
       <p:sp>
         <p:nvSpPr>
-          <p:cNvPr id="54" name="Text 50"/>
+          <p:cNvPr id="56" name="Text 52"/>
           <p:cNvSpPr txBox="1"/>
           <p:nvPr/>
         </p:nvSpPr>
@@ -2605,7 +2667,7 @@
       </p:sp>
       <p:sp>
         <p:nvSpPr>
-          <p:cNvPr id="55" name="Shape 51"/>
+          <p:cNvPr id="57" name="Shape 53"/>
           <p:cNvSpPr/>
           <p:nvPr/>
         </p:nvSpPr>
@@ -2639,7 +2701,7 @@
       </p:sp>
       <p:sp>
         <p:nvSpPr>
-          <p:cNvPr id="56" name="Shape 52"/>
+          <p:cNvPr id="58" name="Shape 54"/>
           <p:cNvSpPr/>
           <p:nvPr/>
         </p:nvSpPr>
@@ -2666,7 +2728,7 @@
       </p:sp>
       <p:sp>
         <p:nvSpPr>
-          <p:cNvPr id="57" name="Shape 53"/>
+          <p:cNvPr id="59" name="Shape 55"/>
           <p:cNvSpPr/>
           <p:nvPr/>
         </p:nvSpPr>
@@ -2693,7 +2755,7 @@
       </p:sp>
       <p:sp>
         <p:nvSpPr>
-          <p:cNvPr id="58" name="Text 54"/>
+          <p:cNvPr id="60" name="Text 56"/>
           <p:cNvSpPr txBox="1"/>
           <p:nvPr/>
         </p:nvSpPr>
@@ -2737,7 +2799,7 @@
       </p:sp>
       <p:sp>
         <p:nvSpPr>
-          <p:cNvPr id="59" name="Text 55"/>
+          <p:cNvPr id="61" name="Text 57"/>
           <p:cNvSpPr txBox="1"/>
           <p:nvPr/>
         </p:nvSpPr>
@@ -2781,7 +2843,7 @@
       </p:sp>
       <p:sp>
         <p:nvSpPr>
-          <p:cNvPr id="60" name="Shape 56"/>
+          <p:cNvPr id="62" name="Shape 58"/>
           <p:cNvSpPr/>
           <p:nvPr/>
         </p:nvSpPr>
@@ -2815,7 +2877,7 @@
       </p:sp>
       <p:sp>
         <p:nvSpPr>
-          <p:cNvPr id="61" name="Shape 57"/>
+          <p:cNvPr id="63" name="Shape 59"/>
           <p:cNvSpPr/>
           <p:nvPr/>
         </p:nvSpPr>
@@ -2842,7 +2904,7 @@
       </p:sp>
       <p:sp>
         <p:nvSpPr>
-          <p:cNvPr id="62" name="Shape 58"/>
+          <p:cNvPr id="64" name="Shape 60"/>
           <p:cNvSpPr/>
           <p:nvPr/>
         </p:nvSpPr>
@@ -2869,7 +2931,7 @@
       </p:sp>
       <p:sp>
         <p:nvSpPr>
-          <p:cNvPr id="63" name="Text 59"/>
+          <p:cNvPr id="65" name="Text 61"/>
           <p:cNvSpPr txBox="1"/>
           <p:nvPr/>
         </p:nvSpPr>
@@ -2913,7 +2975,7 @@
       </p:sp>
       <p:sp>
         <p:nvSpPr>
-          <p:cNvPr id="64" name="Text 60"/>
+          <p:cNvPr id="66" name="Text 62"/>
           <p:cNvSpPr txBox="1"/>
           <p:nvPr/>
         </p:nvSpPr>
@@ -2957,7 +3019,7 @@
       </p:sp>
       <p:sp>
         <p:nvSpPr>
-          <p:cNvPr id="65" name="Shape 61"/>
+          <p:cNvPr id="67" name="Shape 63"/>
           <p:cNvSpPr/>
           <p:nvPr/>
         </p:nvSpPr>
@@ -2991,7 +3053,7 @@
       </p:sp>
       <p:sp>
         <p:nvSpPr>
-          <p:cNvPr id="66" name="Shape 62"/>
+          <p:cNvPr id="68" name="Shape 64"/>
           <p:cNvSpPr/>
           <p:nvPr/>
         </p:nvSpPr>
@@ -3018,7 +3080,7 @@
       </p:sp>
       <p:sp>
         <p:nvSpPr>
-          <p:cNvPr id="67" name="Shape 63"/>
+          <p:cNvPr id="69" name="Shape 65"/>
           <p:cNvSpPr/>
           <p:nvPr/>
         </p:nvSpPr>
@@ -3045,7 +3107,7 @@
       </p:sp>
       <p:sp>
         <p:nvSpPr>
-          <p:cNvPr id="68" name="Text 64"/>
+          <p:cNvPr id="70" name="Text 66"/>
           <p:cNvSpPr txBox="1"/>
           <p:nvPr/>
         </p:nvSpPr>
@@ -3089,7 +3151,7 @@
       </p:sp>
       <p:sp>
         <p:nvSpPr>
-          <p:cNvPr id="69" name="Text 65"/>
+          <p:cNvPr id="71" name="Text 67"/>
           <p:cNvSpPr txBox="1"/>
           <p:nvPr/>
         </p:nvSpPr>
@@ -3133,7 +3195,7 @@
       </p:sp>
       <p:sp>
         <p:nvSpPr>
-          <p:cNvPr id="70" name="mdpr:mdpr-markdown-to-editable-pptx-de2396:feature-summary:mdpr-markdown-to-editable-pptx-de2396-teaser-overview"/>
+          <p:cNvPr id="72" name="mdpr:mdpr-markdown-to-editable-pptx-de2396:feature-summary:mdpr-markdown-to-editable-pptx-de2396-teaser-overview"/>
           <p:cNvSpPr txBox="1"/>
           <p:nvPr/>
         </p:nvSpPr>
@@ -3312,7 +3374,7 @@
       </p:sp>
       <p:graphicFrame>
         <p:nvGraphicFramePr>
-          <p:cNvPr id="71" name="Chart 0" descr=""/>
+          <p:cNvPr id="73" name="Chart 0" descr=""/>
           <p:cNvGraphicFramePr/>
           <p:nvPr/>
         </p:nvGraphicFramePr>

</xml_diff>

<commit_message>
Raise pipeline teaser typography floor
</commit_message>
<xml_diff>
--- a/docs/assets/readme-teaser/deck.pptx
+++ b/docs/assets/readme-teaser/deck.pptx
@@ -3221,7 +3221,7 @@
               <a:buNone/>
             </a:pPr>
             <a:r>
-              <a:rPr lang="en-US" sz="1400" b="1" dirty="0">
+              <a:rPr lang="en-US" sz="1600" b="1" dirty="0">
                 <a:solidFill>
                   <a:srgbClr val="0F766E"/>
                 </a:solidFill>
@@ -3238,7 +3238,7 @@
               <a:buNone/>
             </a:pPr>
             <a:r>
-              <a:rPr lang="en-US" sz="1400" dirty="0">
+              <a:rPr lang="en-US" sz="1600" dirty="0">
                 <a:solidFill>
                   <a:srgbClr val="111111"/>
                 </a:solidFill>
@@ -3248,7 +3248,7 @@
               </a:rPr>
               <a:t>  Markdown -&gt; Semantic IR -&gt; Layout Grammar -&gt; Theme Tokens</a:t>
             </a:r>
-            <a:endParaRPr lang="en-US" sz="1400" dirty="0"/>
+            <a:endParaRPr lang="en-US" sz="1600" dirty="0"/>
           </a:p>
           <a:p>
             <a:pPr algn="l" indent="0" marL="0">
@@ -3258,7 +3258,7 @@
               <a:buNone/>
             </a:pPr>
             <a:r>
-              <a:rPr lang="en-US" sz="1400" b="1" dirty="0">
+              <a:rPr lang="en-US" sz="1600" b="1" dirty="0">
                 <a:solidFill>
                   <a:srgbClr val="0F766E"/>
                 </a:solidFill>
@@ -3268,7 +3268,7 @@
               </a:rPr>
               <a:t>- Main Proof</a:t>
             </a:r>
-            <a:endParaRPr lang="en-US" sz="1400" dirty="0"/>
+            <a:endParaRPr lang="en-US" sz="1600" dirty="0"/>
           </a:p>
           <a:p>
             <a:pPr algn="l" indent="0" marL="0">
@@ -3278,7 +3278,7 @@
               <a:buNone/>
             </a:pPr>
             <a:r>
-              <a:rPr lang="en-US" sz="1400" dirty="0">
+              <a:rPr lang="en-US" sz="1600" dirty="0">
                 <a:solidFill>
                   <a:srgbClr val="111111"/>
                 </a:solidFill>
@@ -3288,7 +3288,7 @@
               </a:rPr>
               <a:t>  PPTX first editable slides, PNG previews, HTML/PDF exports.</a:t>
             </a:r>
-            <a:endParaRPr lang="en-US" sz="1400" dirty="0"/>
+            <a:endParaRPr lang="en-US" sz="1600" dirty="0"/>
           </a:p>
           <a:p>
             <a:pPr algn="l" indent="0" marL="0">
@@ -3298,7 +3298,7 @@
               <a:buNone/>
             </a:pPr>
             <a:r>
-              <a:rPr lang="en-US" sz="1400" b="1" dirty="0">
+              <a:rPr lang="en-US" sz="1600" b="1" dirty="0">
                 <a:solidFill>
                   <a:srgbClr val="0F766E"/>
                 </a:solidFill>
@@ -3308,7 +3308,7 @@
               </a:rPr>
               <a:t>- Coverage</a:t>
             </a:r>
-            <a:endParaRPr lang="en-US" sz="1400" dirty="0"/>
+            <a:endParaRPr lang="en-US" sz="1600" dirty="0"/>
           </a:p>
           <a:p>
             <a:pPr algn="l" indent="0" marL="0">
@@ -3318,7 +3318,7 @@
               <a:buNone/>
             </a:pPr>
             <a:r>
-              <a:rPr lang="en-US" sz="1400" dirty="0">
+              <a:rPr lang="en-US" sz="1600" dirty="0">
                 <a:solidFill>
                   <a:srgbClr val="111111"/>
                 </a:solidFill>
@@ -3328,7 +3328,7 @@
               </a:rPr>
               <a:t>  Chart signal: Styles, Patterns, Object families.</a:t>
             </a:r>
-            <a:endParaRPr lang="en-US" sz="1400" dirty="0"/>
+            <a:endParaRPr lang="en-US" sz="1600" dirty="0"/>
           </a:p>
           <a:p>
             <a:pPr algn="l" indent="0" marL="0">
@@ -3338,7 +3338,7 @@
               <a:buNone/>
             </a:pPr>
             <a:r>
-              <a:rPr lang="en-US" sz="1400" b="1" dirty="0">
+              <a:rPr lang="en-US" sz="1600" b="1" dirty="0">
                 <a:solidFill>
                   <a:srgbClr val="0F766E"/>
                 </a:solidFill>
@@ -3348,7 +3348,7 @@
               </a:rPr>
               <a:t>- Boundary</a:t>
             </a:r>
-            <a:endParaRPr lang="en-US" sz="1400" dirty="0"/>
+            <a:endParaRPr lang="en-US" sz="1600" dirty="0"/>
           </a:p>
           <a:p>
             <a:pPr algn="l" indent="0" marL="0">
@@ -3358,7 +3358,7 @@
               <a:buNone/>
             </a:pPr>
             <a:r>
-              <a:rPr lang="en-US" sz="1400" dirty="0">
+              <a:rPr lang="en-US" sz="1600" dirty="0">
                 <a:solidFill>
                   <a:srgbClr val="111111"/>
                 </a:solidFill>
@@ -3368,7 +3368,7 @@
               </a:rPr>
               <a:t>  Table proof: MDPR owns / Skill may hint.</a:t>
             </a:r>
-            <a:endParaRPr lang="en-US" sz="1400" dirty="0"/>
+            <a:endParaRPr lang="en-US" sz="1600" dirty="0"/>
           </a:p>
         </p:txBody>
       </p:sp>
@@ -3562,7 +3562,7 @@
                         <a:buNone/>
                       </a:pPr>
                       <a:r>
-                        <a:rPr lang="en-US" sz="1500" b="1" dirty="0">
+                        <a:rPr lang="en-US" sz="1600" b="1" dirty="0">
                           <a:solidFill>
                             <a:srgbClr val="111111"/>
                           </a:solidFill>
@@ -3572,7 +3572,7 @@
                         </a:rPr>
                         <a:t>layout, theme, objects, output</a:t>
                       </a:r>
-                      <a:endParaRPr lang="en-US" sz="1500" dirty="0">
+                      <a:endParaRPr lang="en-US" sz="1600" dirty="0">
                         <a:latin typeface="Pretendard" charset="0"/>
                         <a:ea typeface="Pretendard" charset="0"/>
                         <a:cs typeface="Pretendard" charset="0"/>
@@ -3627,7 +3627,7 @@
                         <a:buNone/>
                       </a:pPr>
                       <a:r>
-                        <a:rPr lang="en-US" sz="1500" dirty="0">
+                        <a:rPr lang="en-US" sz="1600" dirty="0">
                           <a:solidFill>
                             <a:srgbClr val="111111"/>
                           </a:solidFill>
@@ -3637,7 +3637,7 @@
                         </a:rPr>
                         <a:t>semantic grouping, review notes</a:t>
                       </a:r>
-                      <a:endParaRPr lang="en-US" sz="1500" dirty="0">
+                      <a:endParaRPr lang="en-US" sz="1600" dirty="0">
                         <a:latin typeface="Pretendard" charset="0"/>
                         <a:ea typeface="Pretendard" charset="0"/>
                         <a:cs typeface="Pretendard" charset="0"/>

</xml_diff>